<commit_message>
Conceptual and Logical ERD
</commit_message>
<xml_diff>
--- a/Modules/03-Data-Architect/projects/Project 1 - Human Resources Database Design/report/HR_Database_Design_Project_Arjun_Avalakki_Mohan.pptx
+++ b/Modules/03-Data-Architect/projects/Project 1 - Human Resources Database Design/report/HR_Database_Design_Project_Arjun_Avalakki_Mohan.pptx
@@ -308,7 +308,7 @@
 <file path=ppt/revisionInfo.xml><?xml version="1.0" encoding="utf-8"?>
 <p1510:revInfo xmlns:a="http://schemas.openxmlformats.org/drawingml/2006/main" xmlns:r="http://schemas.openxmlformats.org/officeDocument/2006/relationships" xmlns:p1510="http://schemas.microsoft.com/office/powerpoint/2015/10/main">
   <p1510:revLst>
-    <p1510:client id="{9B6E52DC-C5BE-4542-A4C5-5F92B55F5FAD}" v="78" dt="2026-05-20T03:57:45.726"/>
+    <p1510:client id="{CEECDE29-5A9E-4E44-A6A5-88C1A3F6F982}" v="2" dt="2026-05-21T05:55:29.432"/>
   </p1510:revLst>
 </p1510:revInfo>
 </file>
@@ -318,7 +318,7 @@
   <pc:docChgLst>
     <pc:chgData name="ARJUN AVALAKKI MOHAN" userId="be4ab9aaf12c5868" providerId="LiveId" clId="{C81E60EF-EF5F-4B4B-A4E1-3178676F15CC}"/>
     <pc:docChg chg="undo custSel addSld delSld modSld">
-      <pc:chgData name="ARJUN AVALAKKI MOHAN" userId="be4ab9aaf12c5868" providerId="LiveId" clId="{C81E60EF-EF5F-4B4B-A4E1-3178676F15CC}" dt="2026-05-20T03:58:05.908" v="765" actId="2696"/>
+      <pc:chgData name="ARJUN AVALAKKI MOHAN" userId="be4ab9aaf12c5868" providerId="LiveId" clId="{C81E60EF-EF5F-4B4B-A4E1-3178676F15CC}" dt="2026-05-21T05:56:26.847" v="815" actId="14100"/>
       <pc:docMkLst>
         <pc:docMk/>
       </pc:docMkLst>
@@ -336,13 +336,6 @@
             <ac:spMk id="180" creationId="{00000000-0000-0000-0000-000000000000}"/>
           </ac:spMkLst>
         </pc:spChg>
-      </pc:sldChg>
-      <pc:sldChg chg="del">
-        <pc:chgData name="ARJUN AVALAKKI MOHAN" userId="be4ab9aaf12c5868" providerId="LiveId" clId="{C81E60EF-EF5F-4B4B-A4E1-3178676F15CC}" dt="2026-05-19T04:49:11.549" v="72" actId="47"/>
-        <pc:sldMkLst>
-          <pc:docMk/>
-          <pc:sldMk cId="0" sldId="257"/>
-        </pc:sldMkLst>
       </pc:sldChg>
       <pc:sldChg chg="modNotes">
         <pc:chgData name="ARJUN AVALAKKI MOHAN" userId="be4ab9aaf12c5868" providerId="LiveId" clId="{C81E60EF-EF5F-4B4B-A4E1-3178676F15CC}" dt="2026-05-20T03:54:24.689" v="721"/>
@@ -372,38 +365,6 @@
             <ac:spMk id="2" creationId="{FE40C933-DA7A-1810-91D7-F01F73C610E0}"/>
           </ac:spMkLst>
         </pc:spChg>
-        <pc:spChg chg="add del mod">
-          <ac:chgData name="ARJUN AVALAKKI MOHAN" userId="be4ab9aaf12c5868" providerId="LiveId" clId="{C81E60EF-EF5F-4B4B-A4E1-3178676F15CC}" dt="2026-05-19T05:24:25.796" v="326" actId="478"/>
-          <ac:spMkLst>
-            <pc:docMk/>
-            <pc:sldMk cId="0" sldId="261"/>
-            <ac:spMk id="3" creationId="{44A6DCCF-22A1-B477-2144-B5C0BE8D55FD}"/>
-          </ac:spMkLst>
-        </pc:spChg>
-        <pc:spChg chg="add del mod">
-          <ac:chgData name="ARJUN AVALAKKI MOHAN" userId="be4ab9aaf12c5868" providerId="LiveId" clId="{C81E60EF-EF5F-4B4B-A4E1-3178676F15CC}" dt="2026-05-19T05:17:13.091" v="254" actId="478"/>
-          <ac:spMkLst>
-            <pc:docMk/>
-            <pc:sldMk cId="0" sldId="261"/>
-            <ac:spMk id="4" creationId="{D810D321-9DF3-44AD-BFED-BF8FBDF11615}"/>
-          </ac:spMkLst>
-        </pc:spChg>
-        <pc:spChg chg="add del mod">
-          <ac:chgData name="ARJUN AVALAKKI MOHAN" userId="be4ab9aaf12c5868" providerId="LiveId" clId="{C81E60EF-EF5F-4B4B-A4E1-3178676F15CC}" dt="2026-05-19T05:21:12.256" v="292" actId="478"/>
-          <ac:spMkLst>
-            <pc:docMk/>
-            <pc:sldMk cId="0" sldId="261"/>
-            <ac:spMk id="6" creationId="{BFE94BE5-4FEA-67CF-AC80-5E9681C130C9}"/>
-          </ac:spMkLst>
-        </pc:spChg>
-        <pc:spChg chg="add del mod">
-          <ac:chgData name="ARJUN AVALAKKI MOHAN" userId="be4ab9aaf12c5868" providerId="LiveId" clId="{C81E60EF-EF5F-4B4B-A4E1-3178676F15CC}" dt="2026-05-19T05:21:12.256" v="292" actId="478"/>
-          <ac:spMkLst>
-            <pc:docMk/>
-            <pc:sldMk cId="0" sldId="261"/>
-            <ac:spMk id="8" creationId="{4FA51857-C63C-ACA7-F14C-C506AB41608C}"/>
-          </ac:spMkLst>
-        </pc:spChg>
         <pc:spChg chg="add mod">
           <ac:chgData name="ARJUN AVALAKKI MOHAN" userId="be4ab9aaf12c5868" providerId="LiveId" clId="{C81E60EF-EF5F-4B4B-A4E1-3178676F15CC}" dt="2026-05-19T05:54:56.695" v="560" actId="1076"/>
           <ac:spMkLst>
@@ -420,14 +381,6 @@
             <ac:spMk id="12" creationId="{38CBDC82-8DFC-5ACF-17A9-83D6B73CC543}"/>
           </ac:spMkLst>
         </pc:spChg>
-        <pc:spChg chg="add del mod">
-          <ac:chgData name="ARJUN AVALAKKI MOHAN" userId="be4ab9aaf12c5868" providerId="LiveId" clId="{C81E60EF-EF5F-4B4B-A4E1-3178676F15CC}" dt="2026-05-19T05:51:39.675" v="531" actId="478"/>
-          <ac:spMkLst>
-            <pc:docMk/>
-            <pc:sldMk cId="0" sldId="261"/>
-            <ac:spMk id="14" creationId="{BDEA5CE7-1937-B8A1-E603-3803D6591177}"/>
-          </ac:spMkLst>
-        </pc:spChg>
         <pc:spChg chg="add mod">
           <ac:chgData name="ARJUN AVALAKKI MOHAN" userId="be4ab9aaf12c5868" providerId="LiveId" clId="{C81E60EF-EF5F-4B4B-A4E1-3178676F15CC}" dt="2026-05-19T05:54:48.034" v="558" actId="14100"/>
           <ac:spMkLst>
@@ -442,14 +395,6 @@
             <pc:docMk/>
             <pc:sldMk cId="0" sldId="261"/>
             <ac:spMk id="212" creationId="{00000000-0000-0000-0000-000000000000}"/>
-          </ac:spMkLst>
-        </pc:spChg>
-        <pc:spChg chg="add del mod">
-          <ac:chgData name="ARJUN AVALAKKI MOHAN" userId="be4ab9aaf12c5868" providerId="LiveId" clId="{C81E60EF-EF5F-4B4B-A4E1-3178676F15CC}" dt="2026-05-19T05:52:14.302" v="533" actId="478"/>
-          <ac:spMkLst>
-            <pc:docMk/>
-            <pc:sldMk cId="0" sldId="261"/>
-            <ac:spMk id="213" creationId="{00000000-0000-0000-0000-000000000000}"/>
           </ac:spMkLst>
         </pc:spChg>
       </pc:sldChg>
@@ -513,19 +458,75 @@
           <pc:sldMk cId="0" sldId="266"/>
         </pc:sldMkLst>
       </pc:sldChg>
-      <pc:sldChg chg="modNotes">
-        <pc:chgData name="ARJUN AVALAKKI MOHAN" userId="be4ab9aaf12c5868" providerId="LiveId" clId="{C81E60EF-EF5F-4B4B-A4E1-3178676F15CC}" dt="2026-05-20T03:54:24.689" v="721"/>
+      <pc:sldChg chg="addSp delSp modSp mod modNotes">
+        <pc:chgData name="ARJUN AVALAKKI MOHAN" userId="be4ab9aaf12c5868" providerId="LiveId" clId="{C81E60EF-EF5F-4B4B-A4E1-3178676F15CC}" dt="2026-05-21T05:26:18.368" v="803" actId="692"/>
         <pc:sldMkLst>
           <pc:docMk/>
           <pc:sldMk cId="0" sldId="267"/>
         </pc:sldMkLst>
+        <pc:spChg chg="mod">
+          <ac:chgData name="ARJUN AVALAKKI MOHAN" userId="be4ab9aaf12c5868" providerId="LiveId" clId="{C81E60EF-EF5F-4B4B-A4E1-3178676F15CC}" dt="2026-05-21T05:20:21.790" v="767" actId="6549"/>
+          <ac:spMkLst>
+            <pc:docMk/>
+            <pc:sldMk cId="0" sldId="267"/>
+            <ac:spMk id="249" creationId="{00000000-0000-0000-0000-000000000000}"/>
+          </ac:spMkLst>
+        </pc:spChg>
+        <pc:picChg chg="add del mod">
+          <ac:chgData name="ARJUN AVALAKKI MOHAN" userId="be4ab9aaf12c5868" providerId="LiveId" clId="{C81E60EF-EF5F-4B4B-A4E1-3178676F15CC}" dt="2026-05-21T05:25:39.535" v="796" actId="478"/>
+          <ac:picMkLst>
+            <pc:docMk/>
+            <pc:sldMk cId="0" sldId="267"/>
+            <ac:picMk id="2" creationId="{3DDA4270-4AEF-F9B2-A951-BA71ABA69973}"/>
+          </ac:picMkLst>
+        </pc:picChg>
+        <pc:picChg chg="add mod">
+          <ac:chgData name="ARJUN AVALAKKI MOHAN" userId="be4ab9aaf12c5868" providerId="LiveId" clId="{C81E60EF-EF5F-4B4B-A4E1-3178676F15CC}" dt="2026-05-21T05:26:18.368" v="803" actId="692"/>
+          <ac:picMkLst>
+            <pc:docMk/>
+            <pc:sldMk cId="0" sldId="267"/>
+            <ac:picMk id="4" creationId="{A5722C49-878A-9ADD-0D36-BBD86256153F}"/>
+          </ac:picMkLst>
+        </pc:picChg>
+        <pc:picChg chg="del">
+          <ac:chgData name="ARJUN AVALAKKI MOHAN" userId="be4ab9aaf12c5868" providerId="LiveId" clId="{C81E60EF-EF5F-4B4B-A4E1-3178676F15CC}" dt="2026-05-21T05:20:17.941" v="766" actId="478"/>
+          <ac:picMkLst>
+            <pc:docMk/>
+            <pc:sldMk cId="0" sldId="267"/>
+            <ac:picMk id="250" creationId="{00000000-0000-0000-0000-000000000000}"/>
+          </ac:picMkLst>
+        </pc:picChg>
       </pc:sldChg>
-      <pc:sldChg chg="modNotes">
-        <pc:chgData name="ARJUN AVALAKKI MOHAN" userId="be4ab9aaf12c5868" providerId="LiveId" clId="{C81E60EF-EF5F-4B4B-A4E1-3178676F15CC}" dt="2026-05-20T03:54:24.689" v="721"/>
+      <pc:sldChg chg="addSp delSp modSp mod modNotes">
+        <pc:chgData name="ARJUN AVALAKKI MOHAN" userId="be4ab9aaf12c5868" providerId="LiveId" clId="{C81E60EF-EF5F-4B4B-A4E1-3178676F15CC}" dt="2026-05-21T05:56:26.847" v="815" actId="14100"/>
         <pc:sldMkLst>
           <pc:docMk/>
           <pc:sldMk cId="0" sldId="268"/>
         </pc:sldMkLst>
+        <pc:spChg chg="mod">
+          <ac:chgData name="ARJUN AVALAKKI MOHAN" userId="be4ab9aaf12c5868" providerId="LiveId" clId="{C81E60EF-EF5F-4B4B-A4E1-3178676F15CC}" dt="2026-05-21T05:55:20.654" v="806" actId="20577"/>
+          <ac:spMkLst>
+            <pc:docMk/>
+            <pc:sldMk cId="0" sldId="268"/>
+            <ac:spMk id="256" creationId="{00000000-0000-0000-0000-000000000000}"/>
+          </ac:spMkLst>
+        </pc:spChg>
+        <pc:picChg chg="add mod">
+          <ac:chgData name="ARJUN AVALAKKI MOHAN" userId="be4ab9aaf12c5868" providerId="LiveId" clId="{C81E60EF-EF5F-4B4B-A4E1-3178676F15CC}" dt="2026-05-21T05:56:26.847" v="815" actId="14100"/>
+          <ac:picMkLst>
+            <pc:docMk/>
+            <pc:sldMk cId="0" sldId="268"/>
+            <ac:picMk id="2" creationId="{83237B88-52C8-4925-B904-FB0AF33100D6}"/>
+          </ac:picMkLst>
+        </pc:picChg>
+        <pc:picChg chg="del">
+          <ac:chgData name="ARJUN AVALAKKI MOHAN" userId="be4ab9aaf12c5868" providerId="LiveId" clId="{C81E60EF-EF5F-4B4B-A4E1-3178676F15CC}" dt="2026-05-21T05:55:16.507" v="804" actId="478"/>
+          <ac:picMkLst>
+            <pc:docMk/>
+            <pc:sldMk cId="0" sldId="268"/>
+            <ac:picMk id="257" creationId="{00000000-0000-0000-0000-000000000000}"/>
+          </ac:picMkLst>
+        </pc:picChg>
       </pc:sldChg>
       <pc:sldChg chg="modNotes">
         <pc:chgData name="ARJUN AVALAKKI MOHAN" userId="be4ab9aaf12c5868" providerId="LiveId" clId="{C81E60EF-EF5F-4B4B-A4E1-3178676F15CC}" dt="2026-05-20T03:54:24.689" v="721"/>
@@ -595,55 +596,6 @@
         <pc:sldMkLst>
           <pc:docMk/>
           <pc:sldMk cId="0" sldId="279"/>
-        </pc:sldMkLst>
-      </pc:sldChg>
-      <pc:sldChg chg="del">
-        <pc:chgData name="ARJUN AVALAKKI MOHAN" userId="be4ab9aaf12c5868" providerId="LiveId" clId="{C81E60EF-EF5F-4B4B-A4E1-3178676F15CC}" dt="2026-05-19T05:47:12.719" v="496" actId="47"/>
-        <pc:sldMkLst>
-          <pc:docMk/>
-          <pc:sldMk cId="0" sldId="280"/>
-        </pc:sldMkLst>
-      </pc:sldChg>
-      <pc:sldChg chg="del">
-        <pc:chgData name="ARJUN AVALAKKI MOHAN" userId="be4ab9aaf12c5868" providerId="LiveId" clId="{C81E60EF-EF5F-4B4B-A4E1-3178676F15CC}" dt="2026-05-19T05:47:12.719" v="496" actId="47"/>
-        <pc:sldMkLst>
-          <pc:docMk/>
-          <pc:sldMk cId="0" sldId="281"/>
-        </pc:sldMkLst>
-      </pc:sldChg>
-      <pc:sldChg chg="del">
-        <pc:chgData name="ARJUN AVALAKKI MOHAN" userId="be4ab9aaf12c5868" providerId="LiveId" clId="{C81E60EF-EF5F-4B4B-A4E1-3178676F15CC}" dt="2026-05-19T05:47:12.719" v="496" actId="47"/>
-        <pc:sldMkLst>
-          <pc:docMk/>
-          <pc:sldMk cId="0" sldId="282"/>
-        </pc:sldMkLst>
-      </pc:sldChg>
-      <pc:sldChg chg="del">
-        <pc:chgData name="ARJUN AVALAKKI MOHAN" userId="be4ab9aaf12c5868" providerId="LiveId" clId="{C81E60EF-EF5F-4B4B-A4E1-3178676F15CC}" dt="2026-05-19T05:47:12.719" v="496" actId="47"/>
-        <pc:sldMkLst>
-          <pc:docMk/>
-          <pc:sldMk cId="0" sldId="283"/>
-        </pc:sldMkLst>
-      </pc:sldChg>
-      <pc:sldChg chg="del">
-        <pc:chgData name="ARJUN AVALAKKI MOHAN" userId="be4ab9aaf12c5868" providerId="LiveId" clId="{C81E60EF-EF5F-4B4B-A4E1-3178676F15CC}" dt="2026-05-19T05:47:12.719" v="496" actId="47"/>
-        <pc:sldMkLst>
-          <pc:docMk/>
-          <pc:sldMk cId="0" sldId="284"/>
-        </pc:sldMkLst>
-      </pc:sldChg>
-      <pc:sldChg chg="del">
-        <pc:chgData name="ARJUN AVALAKKI MOHAN" userId="be4ab9aaf12c5868" providerId="LiveId" clId="{C81E60EF-EF5F-4B4B-A4E1-3178676F15CC}" dt="2026-05-19T05:47:39.675" v="497" actId="47"/>
-        <pc:sldMkLst>
-          <pc:docMk/>
-          <pc:sldMk cId="0" sldId="285"/>
-        </pc:sldMkLst>
-      </pc:sldChg>
-      <pc:sldChg chg="del">
-        <pc:chgData name="ARJUN AVALAKKI MOHAN" userId="be4ab9aaf12c5868" providerId="LiveId" clId="{C81E60EF-EF5F-4B4B-A4E1-3178676F15CC}" dt="2026-05-19T05:47:39.675" v="497" actId="47"/>
-        <pc:sldMkLst>
-          <pc:docMk/>
-          <pc:sldMk cId="0" sldId="286"/>
         </pc:sldMkLst>
       </pc:sldChg>
       <pc:sldChg chg="modSp new mod">
@@ -28204,7 +28156,7 @@
               <a:buChar char="●"/>
             </a:pPr>
             <a:r>
-              <a:rPr lang="en" sz="1900" b="1">
+              <a:rPr lang="en" sz="1900" b="1" dirty="0">
                 <a:latin typeface="Open Sans"/>
                 <a:ea typeface="Open Sans"/>
                 <a:cs typeface="Open Sans"/>
@@ -28212,7 +28164,7 @@
               </a:rPr>
               <a:t>Conceptual</a:t>
             </a:r>
-            <a:endParaRPr sz="1900" b="1">
+            <a:endParaRPr sz="1900" b="1" dirty="0">
               <a:latin typeface="Open Sans"/>
               <a:ea typeface="Open Sans"/>
               <a:cs typeface="Open Sans"/>
@@ -28233,7 +28185,7 @@
               <a:buNone/>
             </a:pPr>
             <a:r>
-              <a:rPr lang="en" sz="1200">
+              <a:rPr lang="en" sz="1200" dirty="0">
                 <a:solidFill>
                   <a:srgbClr val="525C65"/>
                 </a:solidFill>
@@ -28247,7 +28199,7 @@
               </a:rPr>
               <a:t>This is the most general level of data modeling. At the conceptual level, you should be thinking about creating entities that represent business objects for the database. Think broadly here. Attributes (or column names) are not required at this point, but relationship lines are required (although Crow's foot notation is not needed at this level). Create at least three entities for this model; thinking about the 3NF will aid you in deciding the type of entities to create.</a:t>
             </a:r>
-            <a:endParaRPr sz="1200">
+            <a:endParaRPr sz="1200" dirty="0">
               <a:solidFill>
                 <a:srgbClr val="525C65"/>
               </a:solidFill>
@@ -28274,7 +28226,7 @@
               <a:buNone/>
             </a:pPr>
             <a:r>
-              <a:rPr lang="en" sz="1200">
+              <a:rPr lang="en" sz="1200" dirty="0">
                 <a:solidFill>
                   <a:srgbClr val="525C65"/>
                 </a:solidFill>
@@ -28288,7 +28240,7 @@
               </a:rPr>
               <a:t>Use Lucidchart’s built-in template for DBMS ER Diagram UML.</a:t>
             </a:r>
-            <a:endParaRPr sz="1200">
+            <a:endParaRPr sz="1200" dirty="0">
               <a:solidFill>
                 <a:srgbClr val="525C65"/>
               </a:solidFill>
@@ -28314,7 +28266,7 @@
               </a:spcAft>
               <a:buNone/>
             </a:pPr>
-            <a:endParaRPr sz="1200">
+            <a:endParaRPr sz="1200" dirty="0">
               <a:solidFill>
                 <a:srgbClr val="525C65"/>
               </a:solidFill>
@@ -28340,48 +28292,7 @@
               </a:spcAft>
               <a:buNone/>
             </a:pPr>
-            <a:r>
-              <a:rPr lang="en" sz="1200">
-                <a:solidFill>
-                  <a:srgbClr val="FF0000"/>
-                </a:solidFill>
-                <a:highlight>
-                  <a:srgbClr val="FFFFFF"/>
-                </a:highlight>
-                <a:latin typeface="Open Sans"/>
-                <a:ea typeface="Open Sans"/>
-                <a:cs typeface="Open Sans"/>
-                <a:sym typeface="Open Sans"/>
-              </a:rPr>
-              <a:t>** Replace example screenshot below with your response</a:t>
-            </a:r>
-            <a:endParaRPr sz="1200">
-              <a:solidFill>
-                <a:srgbClr val="FF0000"/>
-              </a:solidFill>
-              <a:highlight>
-                <a:srgbClr val="FFFFFF"/>
-              </a:highlight>
-              <a:latin typeface="Open Sans"/>
-              <a:ea typeface="Open Sans"/>
-              <a:cs typeface="Open Sans"/>
-              <a:sym typeface="Open Sans"/>
-            </a:endParaRPr>
-          </a:p>
-          <a:p>
-            <a:pPr marL="0" lvl="0" indent="0" algn="l" rtl="0">
-              <a:lnSpc>
-                <a:spcPct val="170000"/>
-              </a:lnSpc>
-              <a:spcBef>
-                <a:spcPts val="0"/>
-              </a:spcBef>
-              <a:spcAft>
-                <a:spcPts val="0"/>
-              </a:spcAft>
-              <a:buNone/>
-            </a:pPr>
-            <a:endParaRPr sz="1200">
+            <a:endParaRPr sz="1200" dirty="0">
               <a:solidFill>
                 <a:srgbClr val="525C65"/>
               </a:solidFill>
@@ -28409,41 +28320,42 @@
               <a:buFont typeface="Arial"/>
               <a:buNone/>
             </a:pPr>
-            <a:endParaRPr sz="1900"/>
+            <a:endParaRPr sz="1900" dirty="0"/>
           </a:p>
         </p:txBody>
       </p:sp>
       <p:pic>
         <p:nvPicPr>
-          <p:cNvPr id="250" name="Google Shape;250;p62"/>
-          <p:cNvPicPr preferRelativeResize="0"/>
+          <p:cNvPr id="4" name="Picture 3">
+            <a:extLst>
+              <a:ext uri="{FF2B5EF4-FFF2-40B4-BE49-F238E27FC236}">
+                <a16:creationId xmlns:a16="http://schemas.microsoft.com/office/drawing/2014/main" id="{A5722C49-878A-9ADD-0D36-BBD86256153F}"/>
+              </a:ext>
+            </a:extLst>
+          </p:cNvPr>
+          <p:cNvPicPr>
+            <a:picLocks noChangeAspect="1"/>
+          </p:cNvPicPr>
           <p:nvPr/>
         </p:nvPicPr>
         <p:blipFill>
-          <a:blip r:embed="rId3">
-            <a:alphaModFix/>
-          </a:blip>
+          <a:blip r:embed="rId3"/>
           <a:stretch>
             <a:fillRect/>
           </a:stretch>
         </p:blipFill>
         <p:spPr>
           <a:xfrm>
-            <a:off x="755850" y="5786403"/>
-            <a:ext cx="6085425" cy="2570274"/>
+            <a:off x="464820" y="5029200"/>
+            <a:ext cx="6850380" cy="4572000"/>
           </a:xfrm>
           <a:prstGeom prst="rect">
             <a:avLst/>
           </a:prstGeom>
-          <a:noFill/>
-          <a:ln w="9525" cap="flat" cmpd="sng">
+          <a:ln>
             <a:solidFill>
-              <a:schemeClr val="dk2"/>
+              <a:schemeClr val="tx1"/>
             </a:solidFill>
-            <a:prstDash val="solid"/>
-            <a:round/>
-            <a:headEnd type="none" w="sm" len="sm"/>
-            <a:tailEnd type="none" w="sm" len="sm"/>
           </a:ln>
         </p:spPr>
       </p:pic>
@@ -28551,7 +28463,7 @@
               <a:buChar char="●"/>
             </a:pPr>
             <a:r>
-              <a:rPr lang="en" sz="1900" b="1">
+              <a:rPr lang="en" sz="1900" b="1" dirty="0">
                 <a:latin typeface="Open Sans"/>
                 <a:ea typeface="Open Sans"/>
                 <a:cs typeface="Open Sans"/>
@@ -28559,7 +28471,7 @@
               </a:rPr>
               <a:t>Logical</a:t>
             </a:r>
-            <a:endParaRPr sz="1900" b="1">
+            <a:endParaRPr sz="1900" b="1" dirty="0">
               <a:latin typeface="Open Sans"/>
               <a:ea typeface="Open Sans"/>
               <a:cs typeface="Open Sans"/>
@@ -28580,7 +28492,7 @@
               <a:buNone/>
             </a:pPr>
             <a:r>
-              <a:rPr lang="en" sz="1400">
+              <a:rPr lang="en" sz="1400" dirty="0">
                 <a:solidFill>
                   <a:srgbClr val="525C65"/>
                 </a:solidFill>
@@ -28594,7 +28506,7 @@
               </a:rPr>
               <a:t>The logical model is the next level of refinement from the conceptual ERD. At this point, you should have normalized the data to the 3NF. Attributes should also be listed now in the ERD. You can still use human-friendly entity and attribute names in the logical model, and while relationship lines are required, Crow's foot notation is still not needed at this point.</a:t>
             </a:r>
-            <a:endParaRPr sz="1400">
+            <a:endParaRPr sz="1400" dirty="0">
               <a:solidFill>
                 <a:srgbClr val="525C65"/>
               </a:solidFill>
@@ -28621,7 +28533,7 @@
               <a:buNone/>
             </a:pPr>
             <a:r>
-              <a:rPr lang="en" sz="1400">
+              <a:rPr lang="en" sz="1400" dirty="0">
                 <a:solidFill>
                   <a:srgbClr val="525C65"/>
                 </a:solidFill>
@@ -28635,7 +28547,7 @@
               </a:rPr>
               <a:t>Use Lucidchart’s built-in template for DBMS ER Diagram UML.</a:t>
             </a:r>
-            <a:endParaRPr sz="1400">
+            <a:endParaRPr sz="1400" dirty="0">
               <a:solidFill>
                 <a:srgbClr val="525C65"/>
               </a:solidFill>
@@ -28649,93 +28561,52 @@
             </a:endParaRPr>
           </a:p>
           <a:p>
+            <a:pPr marL="457200" lvl="0" indent="0" algn="l" rtl="0">
+              <a:spcBef>
+                <a:spcPts val="0"/>
+              </a:spcBef>
+              <a:spcAft>
+                <a:spcPts val="0"/>
+              </a:spcAft>
+              <a:buNone/>
+            </a:pPr>
+            <a:endParaRPr sz="1900" dirty="0"/>
+          </a:p>
+          <a:p>
             <a:pPr marL="0" lvl="0" indent="0" algn="l" rtl="0">
-              <a:lnSpc>
-                <a:spcPct val="170000"/>
-              </a:lnSpc>
-              <a:spcBef>
-                <a:spcPts val="0"/>
-              </a:spcBef>
-              <a:spcAft>
-                <a:spcPts val="0"/>
-              </a:spcAft>
-              <a:buClr>
-                <a:schemeClr val="dk1"/>
-              </a:buClr>
-              <a:buSzPts val="1100"/>
-              <a:buFont typeface="Arial"/>
+              <a:spcBef>
+                <a:spcPts val="1600"/>
+              </a:spcBef>
+              <a:spcAft>
+                <a:spcPts val="0"/>
+              </a:spcAft>
               <a:buNone/>
             </a:pPr>
-            <a:endParaRPr sz="1200">
-              <a:solidFill>
-                <a:srgbClr val="525C65"/>
-              </a:solidFill>
-              <a:highlight>
-                <a:schemeClr val="lt1"/>
-              </a:highlight>
-              <a:latin typeface="Open Sans"/>
-              <a:ea typeface="Open Sans"/>
-              <a:cs typeface="Open Sans"/>
-              <a:sym typeface="Open Sans"/>
-            </a:endParaRPr>
+            <a:endParaRPr sz="1900" dirty="0"/>
           </a:p>
           <a:p>
             <a:pPr marL="0" lvl="0" indent="0" algn="l" rtl="0">
-              <a:lnSpc>
-                <a:spcPct val="170000"/>
-              </a:lnSpc>
-              <a:spcBef>
-                <a:spcPts val="0"/>
-              </a:spcBef>
-              <a:spcAft>
-                <a:spcPts val="0"/>
-              </a:spcAft>
-              <a:buClr>
-                <a:schemeClr val="dk1"/>
-              </a:buClr>
-              <a:buSzPts val="1100"/>
-              <a:buFont typeface="Arial"/>
+              <a:spcBef>
+                <a:spcPts val="1600"/>
+              </a:spcBef>
+              <a:spcAft>
+                <a:spcPts val="0"/>
+              </a:spcAft>
               <a:buNone/>
             </a:pPr>
-            <a:r>
-              <a:rPr lang="en" sz="1200">
-                <a:solidFill>
-                  <a:srgbClr val="FF0000"/>
-                </a:solidFill>
-                <a:highlight>
-                  <a:schemeClr val="lt1"/>
-                </a:highlight>
-                <a:latin typeface="Open Sans"/>
-                <a:ea typeface="Open Sans"/>
-                <a:cs typeface="Open Sans"/>
-                <a:sym typeface="Open Sans"/>
-              </a:rPr>
-              <a:t>** Replace example screenshot below with your response</a:t>
-            </a:r>
-            <a:endParaRPr sz="1400">
-              <a:solidFill>
-                <a:srgbClr val="525C65"/>
-              </a:solidFill>
-              <a:highlight>
-                <a:srgbClr val="FFFFFF"/>
-              </a:highlight>
-              <a:latin typeface="Open Sans"/>
-              <a:ea typeface="Open Sans"/>
-              <a:cs typeface="Open Sans"/>
-              <a:sym typeface="Open Sans"/>
-            </a:endParaRPr>
-          </a:p>
-          <a:p>
-            <a:pPr marL="457200" lvl="0" indent="0" algn="l" rtl="0">
-              <a:spcBef>
-                <a:spcPts val="0"/>
+            <a:endParaRPr sz="1900" dirty="0"/>
+          </a:p>
+          <a:p>
+            <a:pPr marL="0" lvl="0" indent="0" algn="l" rtl="0">
+              <a:spcBef>
+                <a:spcPts val="1600"/>
               </a:spcBef>
               <a:spcAft>
                 <a:spcPts val="0"/>
               </a:spcAft>
               <a:buNone/>
             </a:pPr>
-            <a:endParaRPr sz="1900"/>
+            <a:endParaRPr sz="1900" dirty="0"/>
           </a:p>
           <a:p>
             <a:pPr marL="0" lvl="0" indent="0" algn="l" rtl="0">
@@ -28743,81 +28614,46 @@
                 <a:spcPts val="1600"/>
               </a:spcBef>
               <a:spcAft>
-                <a:spcPts val="0"/>
+                <a:spcPts val="1600"/>
               </a:spcAft>
               <a:buNone/>
             </a:pPr>
-            <a:endParaRPr sz="1900"/>
-          </a:p>
-          <a:p>
-            <a:pPr marL="0" lvl="0" indent="0" algn="l" rtl="0">
-              <a:spcBef>
-                <a:spcPts val="1600"/>
-              </a:spcBef>
-              <a:spcAft>
-                <a:spcPts val="0"/>
-              </a:spcAft>
-              <a:buNone/>
-            </a:pPr>
-            <a:endParaRPr sz="1900"/>
-          </a:p>
-          <a:p>
-            <a:pPr marL="0" lvl="0" indent="0" algn="l" rtl="0">
-              <a:spcBef>
-                <a:spcPts val="1600"/>
-              </a:spcBef>
-              <a:spcAft>
-                <a:spcPts val="0"/>
-              </a:spcAft>
-              <a:buNone/>
-            </a:pPr>
-            <a:endParaRPr sz="1900"/>
-          </a:p>
-          <a:p>
-            <a:pPr marL="0" lvl="0" indent="0" algn="l" rtl="0">
-              <a:spcBef>
-                <a:spcPts val="1600"/>
-              </a:spcBef>
-              <a:spcAft>
-                <a:spcPts val="1600"/>
-              </a:spcAft>
-              <a:buNone/>
-            </a:pPr>
-            <a:endParaRPr sz="1900"/>
+            <a:endParaRPr sz="1900" dirty="0"/>
           </a:p>
         </p:txBody>
       </p:sp>
       <p:pic>
         <p:nvPicPr>
-          <p:cNvPr id="257" name="Google Shape;257;p63"/>
-          <p:cNvPicPr preferRelativeResize="0"/>
+          <p:cNvPr id="2" name="Picture 1">
+            <a:extLst>
+              <a:ext uri="{FF2B5EF4-FFF2-40B4-BE49-F238E27FC236}">
+                <a16:creationId xmlns:a16="http://schemas.microsoft.com/office/drawing/2014/main" id="{83237B88-52C8-4925-B904-FB0AF33100D6}"/>
+              </a:ext>
+            </a:extLst>
+          </p:cNvPr>
+          <p:cNvPicPr>
+            <a:picLocks noChangeAspect="1"/>
+          </p:cNvPicPr>
           <p:nvPr/>
         </p:nvPicPr>
         <p:blipFill>
-          <a:blip r:embed="rId3">
-            <a:alphaModFix/>
-          </a:blip>
+          <a:blip r:embed="rId3"/>
           <a:stretch>
             <a:fillRect/>
           </a:stretch>
         </p:blipFill>
         <p:spPr>
           <a:xfrm>
-            <a:off x="484950" y="5969175"/>
-            <a:ext cx="6802502" cy="3038826"/>
+            <a:off x="264850" y="5280660"/>
+            <a:ext cx="7242600" cy="4579620"/>
           </a:xfrm>
           <a:prstGeom prst="rect">
             <a:avLst/>
           </a:prstGeom>
-          <a:noFill/>
-          <a:ln w="9525" cap="flat" cmpd="sng">
+          <a:ln>
             <a:solidFill>
-              <a:schemeClr val="dk2"/>
+              <a:schemeClr val="tx1"/>
             </a:solidFill>
-            <a:prstDash val="solid"/>
-            <a:round/>
-            <a:headEnd type="none" w="sm" len="sm"/>
-            <a:tailEnd type="none" w="sm" len="sm"/>
           </a:ln>
         </p:spPr>
       </p:pic>

</xml_diff>

<commit_message>
updated conceptual, logical and physical diagram
</commit_message>
<xml_diff>
--- a/Modules/03-Data-Architect/projects/Project 1 - Human Resources Database Design/report/HR_Database_Design_Project_Arjun_Avalakki_Mohan.pptx
+++ b/Modules/03-Data-Architect/projects/Project 1 - Human Resources Database Design/report/HR_Database_Design_Project_Arjun_Avalakki_Mohan.pptx
@@ -308,7 +308,7 @@
 <file path=ppt/revisionInfo.xml><?xml version="1.0" encoding="utf-8"?>
 <p1510:revInfo xmlns:a="http://schemas.openxmlformats.org/drawingml/2006/main" xmlns:r="http://schemas.openxmlformats.org/officeDocument/2006/relationships" xmlns:p1510="http://schemas.microsoft.com/office/powerpoint/2015/10/main">
   <p1510:revLst>
-    <p1510:client id="{CEECDE29-5A9E-4E44-A6A5-88C1A3F6F982}" v="3" dt="2026-05-22T05:40:33.597"/>
+    <p1510:client id="{CEECDE29-5A9E-4E44-A6A5-88C1A3F6F982}" v="4" dt="2026-05-23T06:15:43.810"/>
   </p1510:revLst>
 </p1510:revInfo>
 </file>
@@ -318,7 +318,7 @@
   <pc:docChgLst>
     <pc:chgData name="ARJUN AVALAKKI MOHAN" userId="be4ab9aaf12c5868" providerId="LiveId" clId="{C81E60EF-EF5F-4B4B-A4E1-3178676F15CC}"/>
     <pc:docChg chg="undo custSel addSld delSld modSld">
-      <pc:chgData name="ARJUN AVALAKKI MOHAN" userId="be4ab9aaf12c5868" providerId="LiveId" clId="{C81E60EF-EF5F-4B4B-A4E1-3178676F15CC}" dt="2026-05-22T05:44:14.498" v="833" actId="692"/>
+      <pc:chgData name="ARJUN AVALAKKI MOHAN" userId="be4ab9aaf12c5868" providerId="LiveId" clId="{C81E60EF-EF5F-4B4B-A4E1-3178676F15CC}" dt="2026-05-23T06:18:14.503" v="897" actId="2085"/>
       <pc:docMkLst>
         <pc:docMk/>
       </pc:docMkLst>
@@ -459,7 +459,7 @@
         </pc:sldMkLst>
       </pc:sldChg>
       <pc:sldChg chg="addSp delSp modSp mod modNotes">
-        <pc:chgData name="ARJUN AVALAKKI MOHAN" userId="be4ab9aaf12c5868" providerId="LiveId" clId="{C81E60EF-EF5F-4B4B-A4E1-3178676F15CC}" dt="2026-05-21T05:26:18.368" v="803" actId="692"/>
+        <pc:chgData name="ARJUN AVALAKKI MOHAN" userId="be4ab9aaf12c5868" providerId="LiveId" clId="{C81E60EF-EF5F-4B4B-A4E1-3178676F15CC}" dt="2026-05-23T06:18:14.503" v="897" actId="2085"/>
         <pc:sldMkLst>
           <pc:docMk/>
           <pc:sldMk cId="0" sldId="267"/>
@@ -472,70 +472,62 @@
             <ac:spMk id="249" creationId="{00000000-0000-0000-0000-000000000000}"/>
           </ac:spMkLst>
         </pc:spChg>
-        <pc:picChg chg="add del mod">
-          <ac:chgData name="ARJUN AVALAKKI MOHAN" userId="be4ab9aaf12c5868" providerId="LiveId" clId="{C81E60EF-EF5F-4B4B-A4E1-3178676F15CC}" dt="2026-05-21T05:25:39.535" v="796" actId="478"/>
+        <pc:picChg chg="add mod">
+          <ac:chgData name="ARJUN AVALAKKI MOHAN" userId="be4ab9aaf12c5868" providerId="LiveId" clId="{C81E60EF-EF5F-4B4B-A4E1-3178676F15CC}" dt="2026-05-23T06:18:14.503" v="897" actId="2085"/>
           <ac:picMkLst>
             <pc:docMk/>
             <pc:sldMk cId="0" sldId="267"/>
-            <ac:picMk id="2" creationId="{3DDA4270-4AEF-F9B2-A951-BA71ABA69973}"/>
+            <ac:picMk id="3" creationId="{0FA426DF-3EB2-5B29-14C6-AD8D9874DE10}"/>
           </ac:picMkLst>
         </pc:picChg>
-        <pc:picChg chg="add mod">
-          <ac:chgData name="ARJUN AVALAKKI MOHAN" userId="be4ab9aaf12c5868" providerId="LiveId" clId="{C81E60EF-EF5F-4B4B-A4E1-3178676F15CC}" dt="2026-05-21T05:26:18.368" v="803" actId="692"/>
+        <pc:picChg chg="add del mod">
+          <ac:chgData name="ARJUN AVALAKKI MOHAN" userId="be4ab9aaf12c5868" providerId="LiveId" clId="{C81E60EF-EF5F-4B4B-A4E1-3178676F15CC}" dt="2026-05-23T06:14:11.556" v="864" actId="478"/>
           <ac:picMkLst>
             <pc:docMk/>
             <pc:sldMk cId="0" sldId="267"/>
             <ac:picMk id="4" creationId="{A5722C49-878A-9ADD-0D36-BBD86256153F}"/>
           </ac:picMkLst>
         </pc:picChg>
-        <pc:picChg chg="del">
-          <ac:chgData name="ARJUN AVALAKKI MOHAN" userId="be4ab9aaf12c5868" providerId="LiveId" clId="{C81E60EF-EF5F-4B4B-A4E1-3178676F15CC}" dt="2026-05-21T05:20:17.941" v="766" actId="478"/>
-          <ac:picMkLst>
-            <pc:docMk/>
-            <pc:sldMk cId="0" sldId="267"/>
-            <ac:picMk id="250" creationId="{00000000-0000-0000-0000-000000000000}"/>
-          </ac:picMkLst>
-        </pc:picChg>
       </pc:sldChg>
       <pc:sldChg chg="addSp delSp modSp mod modNotes">
-        <pc:chgData name="ARJUN AVALAKKI MOHAN" userId="be4ab9aaf12c5868" providerId="LiveId" clId="{C81E60EF-EF5F-4B4B-A4E1-3178676F15CC}" dt="2026-05-21T05:56:26.847" v="815" actId="14100"/>
+        <pc:chgData name="ARJUN AVALAKKI MOHAN" userId="be4ab9aaf12c5868" providerId="LiveId" clId="{C81E60EF-EF5F-4B4B-A4E1-3178676F15CC}" dt="2026-05-23T06:18:07.555" v="896" actId="2085"/>
         <pc:sldMkLst>
           <pc:docMk/>
           <pc:sldMk cId="0" sldId="268"/>
         </pc:sldMkLst>
         <pc:spChg chg="mod">
-          <ac:chgData name="ARJUN AVALAKKI MOHAN" userId="be4ab9aaf12c5868" providerId="LiveId" clId="{C81E60EF-EF5F-4B4B-A4E1-3178676F15CC}" dt="2026-05-21T05:55:20.654" v="806" actId="20577"/>
+          <ac:chgData name="ARJUN AVALAKKI MOHAN" userId="be4ab9aaf12c5868" providerId="LiveId" clId="{C81E60EF-EF5F-4B4B-A4E1-3178676F15CC}" dt="2026-05-23T06:15:53.168" v="877" actId="1076"/>
           <ac:spMkLst>
             <pc:docMk/>
             <pc:sldMk cId="0" sldId="268"/>
             <ac:spMk id="256" creationId="{00000000-0000-0000-0000-000000000000}"/>
           </ac:spMkLst>
         </pc:spChg>
-        <pc:picChg chg="add mod">
-          <ac:chgData name="ARJUN AVALAKKI MOHAN" userId="be4ab9aaf12c5868" providerId="LiveId" clId="{C81E60EF-EF5F-4B4B-A4E1-3178676F15CC}" dt="2026-05-21T05:56:26.847" v="815" actId="14100"/>
+        <pc:picChg chg="add del mod">
+          <ac:chgData name="ARJUN AVALAKKI MOHAN" userId="be4ab9aaf12c5868" providerId="LiveId" clId="{C81E60EF-EF5F-4B4B-A4E1-3178676F15CC}" dt="2026-05-23T06:15:20.790" v="874" actId="478"/>
           <ac:picMkLst>
             <pc:docMk/>
             <pc:sldMk cId="0" sldId="268"/>
             <ac:picMk id="2" creationId="{83237B88-52C8-4925-B904-FB0AF33100D6}"/>
           </ac:picMkLst>
         </pc:picChg>
-        <pc:picChg chg="del">
-          <ac:chgData name="ARJUN AVALAKKI MOHAN" userId="be4ab9aaf12c5868" providerId="LiveId" clId="{C81E60EF-EF5F-4B4B-A4E1-3178676F15CC}" dt="2026-05-21T05:55:16.507" v="804" actId="478"/>
+        <pc:picChg chg="add mod">
+          <ac:chgData name="ARJUN AVALAKKI MOHAN" userId="be4ab9aaf12c5868" providerId="LiveId" clId="{C81E60EF-EF5F-4B4B-A4E1-3178676F15CC}" dt="2026-05-23T06:18:07.555" v="896" actId="2085"/>
           <ac:picMkLst>
             <pc:docMk/>
             <pc:sldMk cId="0" sldId="268"/>
-            <ac:picMk id="257" creationId="{00000000-0000-0000-0000-000000000000}"/>
+            <ac:picMk id="3" creationId="{C331EB5E-11D8-4A6D-0411-2A0C93A01961}"/>
           </ac:picMkLst>
         </pc:picChg>
       </pc:sldChg>
       <pc:sldChg chg="addSp delSp modSp mod modNotes">
-        <pc:chgData name="ARJUN AVALAKKI MOHAN" userId="be4ab9aaf12c5868" providerId="LiveId" clId="{C81E60EF-EF5F-4B4B-A4E1-3178676F15CC}" dt="2026-05-22T05:44:14.498" v="833" actId="692"/>
+        <pc:chgData name="ARJUN AVALAKKI MOHAN" userId="be4ab9aaf12c5868" providerId="LiveId" clId="{C81E60EF-EF5F-4B4B-A4E1-3178676F15CC}" dt="2026-05-23T06:17:57.735" v="895" actId="2085"/>
         <pc:sldMkLst>
           <pc:docMk/>
           <pc:sldMk cId="0" sldId="269"/>
         </pc:sldMkLst>
         <pc:spChg chg="mod">
-          <ac:chgData name="ARJUN AVALAKKI MOHAN" userId="be4ab9aaf12c5868" providerId="LiveId" clId="{C81E60EF-EF5F-4B4B-A4E1-3178676F15CC}" dt="2026-05-22T05:40:30.391" v="817" actId="6549"/>
+          <ac:chgData name="ARJUN AVALAKKI MOHAN" userId="be4ab9aaf12c5868" providerId="LiveId" clId="{C81E60EF-EF5F-4B4B-A4E1-3178676F15CC}" dt="2026-05-23T06:16:43.534" v="885" actId="14100"/>
           <ac:spMkLst>
             <pc:docMk/>
             <pc:sldMk cId="0" sldId="269"/>
@@ -551,7 +543,15 @@
           </ac:picMkLst>
         </pc:picChg>
         <pc:picChg chg="add mod">
-          <ac:chgData name="ARJUN AVALAKKI MOHAN" userId="be4ab9aaf12c5868" providerId="LiveId" clId="{C81E60EF-EF5F-4B4B-A4E1-3178676F15CC}" dt="2026-05-22T05:44:14.498" v="833" actId="692"/>
+          <ac:chgData name="ARJUN AVALAKKI MOHAN" userId="be4ab9aaf12c5868" providerId="LiveId" clId="{C81E60EF-EF5F-4B4B-A4E1-3178676F15CC}" dt="2026-05-23T06:17:57.735" v="895" actId="2085"/>
+          <ac:picMkLst>
+            <pc:docMk/>
+            <pc:sldMk cId="0" sldId="269"/>
+            <ac:picMk id="3" creationId="{4FDF5F04-A16A-8719-A692-B9C7214704D4}"/>
+          </ac:picMkLst>
+        </pc:picChg>
+        <pc:picChg chg="add del mod">
+          <ac:chgData name="ARJUN AVALAKKI MOHAN" userId="be4ab9aaf12c5868" providerId="LiveId" clId="{C81E60EF-EF5F-4B4B-A4E1-3178676F15CC}" dt="2026-05-23T06:16:33.201" v="883" actId="478"/>
           <ac:picMkLst>
             <pc:docMk/>
             <pc:sldMk cId="0" sldId="269"/>
@@ -574,12 +574,52 @@
           <pc:sldMk cId="0" sldId="271"/>
         </pc:sldMkLst>
       </pc:sldChg>
-      <pc:sldChg chg="modNotes">
-        <pc:chgData name="ARJUN AVALAKKI MOHAN" userId="be4ab9aaf12c5868" providerId="LiveId" clId="{C81E60EF-EF5F-4B4B-A4E1-3178676F15CC}" dt="2026-05-20T03:54:24.689" v="721"/>
+      <pc:sldChg chg="addSp delSp modSp mod modNotes">
+        <pc:chgData name="ARJUN AVALAKKI MOHAN" userId="be4ab9aaf12c5868" providerId="LiveId" clId="{C81E60EF-EF5F-4B4B-A4E1-3178676F15CC}" dt="2026-05-23T04:57:50.654" v="863" actId="14100"/>
         <pc:sldMkLst>
           <pc:docMk/>
           <pc:sldMk cId="0" sldId="272"/>
         </pc:sldMkLst>
+        <pc:spChg chg="mod">
+          <ac:chgData name="ARJUN AVALAKKI MOHAN" userId="be4ab9aaf12c5868" providerId="LiveId" clId="{C81E60EF-EF5F-4B4B-A4E1-3178676F15CC}" dt="2026-05-23T04:56:27.298" v="854" actId="6549"/>
+          <ac:spMkLst>
+            <pc:docMk/>
+            <pc:sldMk cId="0" sldId="272"/>
+            <ac:spMk id="282" creationId="{00000000-0000-0000-0000-000000000000}"/>
+          </ac:spMkLst>
+        </pc:spChg>
+        <pc:picChg chg="add mod">
+          <ac:chgData name="ARJUN AVALAKKI MOHAN" userId="be4ab9aaf12c5868" providerId="LiveId" clId="{C81E60EF-EF5F-4B4B-A4E1-3178676F15CC}" dt="2026-05-23T04:57:48.176" v="862" actId="14100"/>
+          <ac:picMkLst>
+            <pc:docMk/>
+            <pc:sldMk cId="0" sldId="272"/>
+            <ac:picMk id="3" creationId="{76232950-6D82-5068-3105-506D04C9CEFB}"/>
+          </ac:picMkLst>
+        </pc:picChg>
+        <pc:picChg chg="add mod">
+          <ac:chgData name="ARJUN AVALAKKI MOHAN" userId="be4ab9aaf12c5868" providerId="LiveId" clId="{C81E60EF-EF5F-4B4B-A4E1-3178676F15CC}" dt="2026-05-23T04:57:50.654" v="863" actId="14100"/>
+          <ac:picMkLst>
+            <pc:docMk/>
+            <pc:sldMk cId="0" sldId="272"/>
+            <ac:picMk id="5" creationId="{28FE4F40-9295-B4A4-C7A6-585514873CBB}"/>
+          </ac:picMkLst>
+        </pc:picChg>
+        <pc:picChg chg="add mod">
+          <ac:chgData name="ARJUN AVALAKKI MOHAN" userId="be4ab9aaf12c5868" providerId="LiveId" clId="{C81E60EF-EF5F-4B4B-A4E1-3178676F15CC}" dt="2026-05-23T04:57:44.480" v="861" actId="1076"/>
+          <ac:picMkLst>
+            <pc:docMk/>
+            <pc:sldMk cId="0" sldId="272"/>
+            <ac:picMk id="7" creationId="{900B74AF-50A8-EDCD-6B4E-3FA9662EE864}"/>
+          </ac:picMkLst>
+        </pc:picChg>
+        <pc:picChg chg="del">
+          <ac:chgData name="ARJUN AVALAKKI MOHAN" userId="be4ab9aaf12c5868" providerId="LiveId" clId="{C81E60EF-EF5F-4B4B-A4E1-3178676F15CC}" dt="2026-05-23T04:40:01.333" v="834" actId="478"/>
+          <ac:picMkLst>
+            <pc:docMk/>
+            <pc:sldMk cId="0" sldId="272"/>
+            <ac:picMk id="283" creationId="{00000000-0000-0000-0000-000000000000}"/>
+          </ac:picMkLst>
+        </pc:picChg>
       </pc:sldChg>
       <pc:sldChg chg="modNotes">
         <pc:chgData name="ARJUN AVALAKKI MOHAN" userId="be4ab9aaf12c5868" providerId="LiveId" clId="{C81E60EF-EF5F-4B4B-A4E1-3178676F15CC}" dt="2026-05-20T03:54:24.689" v="721"/>
@@ -28343,10 +28383,10 @@
       </p:sp>
       <p:pic>
         <p:nvPicPr>
-          <p:cNvPr id="4" name="Picture 3">
+          <p:cNvPr id="3" name="Picture 2">
             <a:extLst>
               <a:ext uri="{FF2B5EF4-FFF2-40B4-BE49-F238E27FC236}">
-                <a16:creationId xmlns:a16="http://schemas.microsoft.com/office/drawing/2014/main" id="{A5722C49-878A-9ADD-0D36-BBD86256153F}"/>
+                <a16:creationId xmlns:a16="http://schemas.microsoft.com/office/drawing/2014/main" id="{0FA426DF-3EB2-5B29-14C6-AD8D9874DE10}"/>
               </a:ext>
             </a:extLst>
           </p:cNvPr>
@@ -28363,16 +28403,14 @@
         </p:blipFill>
         <p:spPr>
           <a:xfrm>
-            <a:off x="464820" y="5029200"/>
-            <a:ext cx="6850380" cy="4572000"/>
+            <a:off x="264850" y="5313680"/>
+            <a:ext cx="6969070" cy="3312160"/>
           </a:xfrm>
           <a:prstGeom prst="rect">
             <a:avLst/>
           </a:prstGeom>
           <a:ln>
-            <a:solidFill>
-              <a:schemeClr val="tx1"/>
-            </a:solidFill>
+            <a:noFill/>
           </a:ln>
         </p:spPr>
       </p:pic>
@@ -28455,7 +28493,7 @@
         </p:nvSpPr>
         <p:spPr>
           <a:xfrm>
-            <a:off x="264950" y="2253724"/>
+            <a:off x="264850" y="1816844"/>
             <a:ext cx="7242600" cy="7731900"/>
           </a:xfrm>
           <a:prstGeom prst="rect">
@@ -28641,10 +28679,10 @@
       </p:sp>
       <p:pic>
         <p:nvPicPr>
-          <p:cNvPr id="2" name="Picture 1">
+          <p:cNvPr id="3" name="Picture 2">
             <a:extLst>
               <a:ext uri="{FF2B5EF4-FFF2-40B4-BE49-F238E27FC236}">
-                <a16:creationId xmlns:a16="http://schemas.microsoft.com/office/drawing/2014/main" id="{83237B88-52C8-4925-B904-FB0AF33100D6}"/>
+                <a16:creationId xmlns:a16="http://schemas.microsoft.com/office/drawing/2014/main" id="{C331EB5E-11D8-4A6D-0411-2A0C93A01961}"/>
               </a:ext>
             </a:extLst>
           </p:cNvPr>
@@ -28661,16 +28699,14 @@
         </p:blipFill>
         <p:spPr>
           <a:xfrm>
-            <a:off x="264850" y="5280660"/>
-            <a:ext cx="7242600" cy="4579620"/>
+            <a:off x="345440" y="4798257"/>
+            <a:ext cx="7162010" cy="5087423"/>
           </a:xfrm>
           <a:prstGeom prst="rect">
             <a:avLst/>
           </a:prstGeom>
           <a:ln>
-            <a:solidFill>
-              <a:schemeClr val="tx1"/>
-            </a:solidFill>
+            <a:noFill/>
           </a:ln>
         </p:spPr>
       </p:pic>
@@ -28753,8 +28789,8 @@
         </p:nvSpPr>
         <p:spPr>
           <a:xfrm>
-            <a:off x="264950" y="1990174"/>
-            <a:ext cx="7242600" cy="7731900"/>
+            <a:off x="264900" y="1766654"/>
+            <a:ext cx="7242600" cy="3262546"/>
           </a:xfrm>
           <a:prstGeom prst="rect">
             <a:avLst/>
@@ -28861,10 +28897,10 @@
       </p:sp>
       <p:pic>
         <p:nvPicPr>
-          <p:cNvPr id="4" name="Picture 3">
+          <p:cNvPr id="3" name="Picture 2">
             <a:extLst>
               <a:ext uri="{FF2B5EF4-FFF2-40B4-BE49-F238E27FC236}">
-                <a16:creationId xmlns:a16="http://schemas.microsoft.com/office/drawing/2014/main" id="{ECCD54A3-5A7D-7962-92AF-B50CC087C9F0}"/>
+                <a16:creationId xmlns:a16="http://schemas.microsoft.com/office/drawing/2014/main" id="{4FDF5F04-A16A-8719-A692-B9C7214704D4}"/>
               </a:ext>
             </a:extLst>
           </p:cNvPr>
@@ -28881,16 +28917,14 @@
         </p:blipFill>
         <p:spPr>
           <a:xfrm>
-            <a:off x="420130" y="5343781"/>
-            <a:ext cx="6822470" cy="4170922"/>
+            <a:off x="264900" y="5029200"/>
+            <a:ext cx="7242600" cy="4439920"/>
           </a:xfrm>
           <a:prstGeom prst="rect">
             <a:avLst/>
           </a:prstGeom>
           <a:ln>
-            <a:solidFill>
-              <a:schemeClr val="tx1"/>
-            </a:solidFill>
+            <a:noFill/>
           </a:ln>
         </p:spPr>
       </p:pic>
@@ -30065,328 +30099,149 @@
               <a:buNone/>
             </a:pPr>
             <a:r>
-              <a:rPr lang="en" sz="1900"/>
+              <a:rPr lang="en" sz="1900" dirty="0"/>
               <a:t>Create a DDL SQL script capable of building the database you designed in Step 2</a:t>
             </a:r>
-            <a:endParaRPr sz="1900"/>
-          </a:p>
-          <a:p>
-            <a:pPr marL="241300" marR="241300" lvl="0" indent="0" algn="l" rtl="0">
-              <a:lnSpc>
-                <a:spcPct val="100000"/>
-              </a:lnSpc>
+            <a:endParaRPr sz="1900" dirty="0"/>
+          </a:p>
+          <a:p>
+            <a:pPr marL="457200" lvl="0" indent="0" algn="l" rtl="0">
+              <a:spcBef>
+                <a:spcPts val="0"/>
+              </a:spcBef>
+              <a:spcAft>
+                <a:spcPts val="0"/>
+              </a:spcAft>
+              <a:buNone/>
+            </a:pPr>
+            <a:endParaRPr sz="1900" dirty="0"/>
+          </a:p>
+          <a:p>
+            <a:pPr marL="457200" lvl="0" indent="0" algn="l" rtl="0">
               <a:spcBef>
                 <a:spcPts val="1600"/>
               </a:spcBef>
               <a:spcAft>
                 <a:spcPts val="0"/>
               </a:spcAft>
-              <a:buClr>
-                <a:schemeClr val="dk1"/>
-              </a:buClr>
-              <a:buSzPts val="1100"/>
-              <a:buFont typeface="Arial"/>
               <a:buNone/>
             </a:pPr>
-            <a:r>
-              <a:rPr lang="en" sz="1350" b="1">
-                <a:solidFill>
-                  <a:srgbClr val="2E3D49"/>
-                </a:solidFill>
-                <a:highlight>
-                  <a:srgbClr val="FFFFFF"/>
-                </a:highlight>
-                <a:latin typeface="Open Sans"/>
-                <a:ea typeface="Open Sans"/>
-                <a:cs typeface="Open Sans"/>
-                <a:sym typeface="Open Sans"/>
-              </a:rPr>
-              <a:t>Hints</a:t>
-            </a:r>
-            <a:endParaRPr sz="1350" b="1">
-              <a:solidFill>
-                <a:srgbClr val="2E3D49"/>
-              </a:solidFill>
-              <a:highlight>
-                <a:srgbClr val="FFFFFF"/>
-              </a:highlight>
-              <a:latin typeface="Open Sans"/>
-              <a:ea typeface="Open Sans"/>
-              <a:cs typeface="Open Sans"/>
-              <a:sym typeface="Open Sans"/>
-            </a:endParaRPr>
-          </a:p>
-          <a:p>
-            <a:pPr marL="241300" marR="241300" lvl="0" indent="0" algn="l" rtl="0">
-              <a:lnSpc>
-                <a:spcPct val="100000"/>
-              </a:lnSpc>
-              <a:spcBef>
-                <a:spcPts val="0"/>
-              </a:spcBef>
-              <a:spcAft>
-                <a:spcPts val="0"/>
-              </a:spcAft>
-              <a:buClr>
-                <a:schemeClr val="dk1"/>
-              </a:buClr>
-              <a:buSzPts val="1100"/>
-              <a:buFont typeface="Arial"/>
+            <a:endParaRPr sz="1900" dirty="0"/>
+          </a:p>
+          <a:p>
+            <a:pPr marL="457200" lvl="0" indent="0" algn="l" rtl="0">
+              <a:spcBef>
+                <a:spcPts val="1600"/>
+              </a:spcBef>
+              <a:spcAft>
+                <a:spcPts val="0"/>
+              </a:spcAft>
               <a:buNone/>
             </a:pPr>
-            <a:r>
-              <a:rPr lang="en" sz="1350">
-                <a:solidFill>
-                  <a:srgbClr val="525C65"/>
-                </a:solidFill>
-                <a:highlight>
-                  <a:srgbClr val="FFFFFF"/>
-                </a:highlight>
-                <a:latin typeface="Open Sans"/>
-                <a:ea typeface="Open Sans"/>
-                <a:cs typeface="Open Sans"/>
-                <a:sym typeface="Open Sans"/>
-              </a:rPr>
-              <a:t>The DDL script will be graded by running the code you submit. Please ensure your SQL code runs properly.</a:t>
-            </a:r>
-            <a:endParaRPr sz="1350">
-              <a:solidFill>
-                <a:srgbClr val="525C65"/>
-              </a:solidFill>
-              <a:highlight>
-                <a:srgbClr val="FFFFFF"/>
-              </a:highlight>
-              <a:latin typeface="Open Sans"/>
-              <a:ea typeface="Open Sans"/>
-              <a:cs typeface="Open Sans"/>
-              <a:sym typeface="Open Sans"/>
-            </a:endParaRPr>
-          </a:p>
-          <a:p>
-            <a:pPr marL="241300" marR="241300" lvl="0" indent="0" algn="l" rtl="0">
-              <a:lnSpc>
-                <a:spcPct val="100000"/>
-              </a:lnSpc>
-              <a:spcBef>
-                <a:spcPts val="0"/>
-              </a:spcBef>
-              <a:spcAft>
-                <a:spcPts val="0"/>
-              </a:spcAft>
-              <a:buClr>
-                <a:schemeClr val="dk1"/>
-              </a:buClr>
-              <a:buSzPts val="1100"/>
-              <a:buFont typeface="Arial"/>
+            <a:endParaRPr sz="1900" dirty="0"/>
+          </a:p>
+          <a:p>
+            <a:pPr marL="457200" lvl="0" indent="0" algn="l" rtl="0">
+              <a:spcBef>
+                <a:spcPts val="1600"/>
+              </a:spcBef>
+              <a:spcAft>
+                <a:spcPts val="1600"/>
+              </a:spcAft>
               <a:buNone/>
             </a:pPr>
-            <a:endParaRPr sz="1350">
-              <a:solidFill>
-                <a:srgbClr val="525C65"/>
-              </a:solidFill>
-              <a:highlight>
-                <a:srgbClr val="FFFFFF"/>
-              </a:highlight>
-              <a:latin typeface="Open Sans"/>
-              <a:ea typeface="Open Sans"/>
-              <a:cs typeface="Open Sans"/>
-              <a:sym typeface="Open Sans"/>
-            </a:endParaRPr>
-          </a:p>
-          <a:p>
-            <a:pPr marL="241300" marR="241300" lvl="0" indent="0" algn="l" rtl="0">
-              <a:lnSpc>
-                <a:spcPct val="100000"/>
-              </a:lnSpc>
-              <a:spcBef>
-                <a:spcPts val="0"/>
-              </a:spcBef>
-              <a:spcAft>
-                <a:spcPts val="0"/>
-              </a:spcAft>
-              <a:buNone/>
-            </a:pPr>
-            <a:r>
-              <a:rPr lang="en" sz="1350">
-                <a:solidFill>
-                  <a:srgbClr val="525C65"/>
-                </a:solidFill>
-                <a:highlight>
-                  <a:srgbClr val="FFFFFF"/>
-                </a:highlight>
-                <a:latin typeface="Open Sans"/>
-                <a:ea typeface="Open Sans"/>
-                <a:cs typeface="Open Sans"/>
-                <a:sym typeface="Open Sans"/>
-              </a:rPr>
-              <a:t>Foreign keys cannot be created on tables that do not exist yet, so it may be easier to create all tables in the database, then to go back and run modify statements on the tables to create foreign key constraints.</a:t>
-            </a:r>
-            <a:endParaRPr sz="1350">
-              <a:solidFill>
-                <a:srgbClr val="525C65"/>
-              </a:solidFill>
-              <a:highlight>
-                <a:srgbClr val="FFFFFF"/>
-              </a:highlight>
-              <a:latin typeface="Open Sans"/>
-              <a:ea typeface="Open Sans"/>
-              <a:cs typeface="Open Sans"/>
-              <a:sym typeface="Open Sans"/>
-            </a:endParaRPr>
-          </a:p>
-          <a:p>
-            <a:pPr marL="241300" marR="241300" lvl="0" indent="0" algn="l" rtl="0">
-              <a:lnSpc>
-                <a:spcPct val="100000"/>
-              </a:lnSpc>
-              <a:spcBef>
-                <a:spcPts val="0"/>
-              </a:spcBef>
-              <a:spcAft>
-                <a:spcPts val="0"/>
-              </a:spcAft>
-              <a:buNone/>
-            </a:pPr>
-            <a:endParaRPr sz="1350">
-              <a:solidFill>
-                <a:srgbClr val="2E3D49"/>
-              </a:solidFill>
-              <a:highlight>
-                <a:srgbClr val="FFFFFF"/>
-              </a:highlight>
-              <a:latin typeface="Open Sans"/>
-              <a:ea typeface="Open Sans"/>
-              <a:cs typeface="Open Sans"/>
-              <a:sym typeface="Open Sans"/>
-            </a:endParaRPr>
-          </a:p>
-          <a:p>
-            <a:pPr marL="241300" marR="241300" lvl="0" indent="0" algn="l" rtl="0">
-              <a:lnSpc>
-                <a:spcPct val="100000"/>
-              </a:lnSpc>
-              <a:spcBef>
-                <a:spcPts val="0"/>
-              </a:spcBef>
-              <a:spcAft>
-                <a:spcPts val="0"/>
-              </a:spcAft>
-              <a:buClr>
-                <a:schemeClr val="dk1"/>
-              </a:buClr>
-              <a:buSzPts val="1100"/>
-              <a:buFont typeface="Arial"/>
-              <a:buNone/>
-            </a:pPr>
-            <a:r>
-              <a:rPr lang="en" sz="1350">
-                <a:solidFill>
-                  <a:srgbClr val="FF0000"/>
-                </a:solidFill>
-                <a:highlight>
-                  <a:srgbClr val="FFFFFF"/>
-                </a:highlight>
-                <a:latin typeface="Open Sans"/>
-                <a:ea typeface="Open Sans"/>
-                <a:cs typeface="Open Sans"/>
-                <a:sym typeface="Open Sans"/>
-              </a:rPr>
-              <a:t>Remember to submit the related SQL file as well, not just a screenshot (replace the below screenshot).</a:t>
-            </a:r>
-            <a:endParaRPr sz="1350">
-              <a:solidFill>
-                <a:srgbClr val="FF0000"/>
-              </a:solidFill>
-              <a:highlight>
-                <a:srgbClr val="FFFFFF"/>
-              </a:highlight>
-              <a:latin typeface="Open Sans"/>
-              <a:ea typeface="Open Sans"/>
-              <a:cs typeface="Open Sans"/>
-              <a:sym typeface="Open Sans"/>
-            </a:endParaRPr>
-          </a:p>
-          <a:p>
-            <a:pPr marL="457200" lvl="0" indent="0" algn="l" rtl="0">
-              <a:spcBef>
-                <a:spcPts val="0"/>
-              </a:spcBef>
-              <a:spcAft>
-                <a:spcPts val="0"/>
-              </a:spcAft>
-              <a:buNone/>
-            </a:pPr>
-            <a:endParaRPr sz="1900"/>
-          </a:p>
-          <a:p>
-            <a:pPr marL="457200" lvl="0" indent="0" algn="l" rtl="0">
-              <a:spcBef>
-                <a:spcPts val="1600"/>
-              </a:spcBef>
-              <a:spcAft>
-                <a:spcPts val="0"/>
-              </a:spcAft>
-              <a:buNone/>
-            </a:pPr>
-            <a:endParaRPr sz="1900"/>
-          </a:p>
-          <a:p>
-            <a:pPr marL="457200" lvl="0" indent="0" algn="l" rtl="0">
-              <a:spcBef>
-                <a:spcPts val="1600"/>
-              </a:spcBef>
-              <a:spcAft>
-                <a:spcPts val="0"/>
-              </a:spcAft>
-              <a:buNone/>
-            </a:pPr>
-            <a:endParaRPr sz="1900"/>
-          </a:p>
-          <a:p>
-            <a:pPr marL="457200" lvl="0" indent="0" algn="l" rtl="0">
-              <a:spcBef>
-                <a:spcPts val="1600"/>
-              </a:spcBef>
-              <a:spcAft>
-                <a:spcPts val="1600"/>
-              </a:spcAft>
-              <a:buNone/>
-            </a:pPr>
-            <a:endParaRPr sz="1900"/>
+            <a:endParaRPr sz="1900" dirty="0"/>
           </a:p>
         </p:txBody>
       </p:sp>
       <p:pic>
         <p:nvPicPr>
-          <p:cNvPr id="283" name="Google Shape;283;p67"/>
-          <p:cNvPicPr preferRelativeResize="0"/>
+          <p:cNvPr id="3" name="Picture 2">
+            <a:extLst>
+              <a:ext uri="{FF2B5EF4-FFF2-40B4-BE49-F238E27FC236}">
+                <a16:creationId xmlns:a16="http://schemas.microsoft.com/office/drawing/2014/main" id="{76232950-6D82-5068-3105-506D04C9CEFB}"/>
+              </a:ext>
+            </a:extLst>
+          </p:cNvPr>
+          <p:cNvPicPr>
+            <a:picLocks noChangeAspect="1"/>
+          </p:cNvPicPr>
           <p:nvPr/>
         </p:nvPicPr>
-        <p:blipFill rotWithShape="1">
-          <a:blip r:embed="rId3">
-            <a:alphaModFix/>
-          </a:blip>
-          <a:srcRect l="2818" t="2391"/>
-          <a:stretch/>
+        <p:blipFill>
+          <a:blip r:embed="rId3"/>
+          <a:stretch>
+            <a:fillRect/>
+          </a:stretch>
         </p:blipFill>
         <p:spPr>
           <a:xfrm>
-            <a:off x="1641775" y="5527975"/>
-            <a:ext cx="3823475" cy="3971125"/>
+            <a:off x="385900" y="3146975"/>
+            <a:ext cx="3175060" cy="1648910"/>
           </a:xfrm>
           <a:prstGeom prst="rect">
             <a:avLst/>
           </a:prstGeom>
-          <a:noFill/>
-          <a:ln w="9525" cap="flat" cmpd="sng">
-            <a:solidFill>
-              <a:schemeClr val="dk2"/>
-            </a:solidFill>
-            <a:prstDash val="solid"/>
-            <a:round/>
-            <a:headEnd type="none" w="sm" len="sm"/>
-            <a:tailEnd type="none" w="sm" len="sm"/>
-          </a:ln>
+        </p:spPr>
+      </p:pic>
+      <p:pic>
+        <p:nvPicPr>
+          <p:cNvPr id="5" name="Picture 4">
+            <a:extLst>
+              <a:ext uri="{FF2B5EF4-FFF2-40B4-BE49-F238E27FC236}">
+                <a16:creationId xmlns:a16="http://schemas.microsoft.com/office/drawing/2014/main" id="{28FE4F40-9295-B4A4-C7A6-585514873CBB}"/>
+              </a:ext>
+            </a:extLst>
+          </p:cNvPr>
+          <p:cNvPicPr>
+            <a:picLocks noChangeAspect="1"/>
+          </p:cNvPicPr>
+          <p:nvPr/>
+        </p:nvPicPr>
+        <p:blipFill>
+          <a:blip r:embed="rId4"/>
+          <a:stretch>
+            <a:fillRect/>
+          </a:stretch>
+        </p:blipFill>
+        <p:spPr>
+          <a:xfrm>
+            <a:off x="385899" y="4795885"/>
+            <a:ext cx="3175060" cy="4778190"/>
+          </a:xfrm>
+          <a:prstGeom prst="rect">
+            <a:avLst/>
+          </a:prstGeom>
+        </p:spPr>
+      </p:pic>
+      <p:pic>
+        <p:nvPicPr>
+          <p:cNvPr id="7" name="Picture 6">
+            <a:extLst>
+              <a:ext uri="{FF2B5EF4-FFF2-40B4-BE49-F238E27FC236}">
+                <a16:creationId xmlns:a16="http://schemas.microsoft.com/office/drawing/2014/main" id="{900B74AF-50A8-EDCD-6B4E-3FA9662EE864}"/>
+              </a:ext>
+            </a:extLst>
+          </p:cNvPr>
+          <p:cNvPicPr>
+            <a:picLocks noChangeAspect="1"/>
+          </p:cNvPicPr>
+          <p:nvPr/>
+        </p:nvPicPr>
+        <p:blipFill>
+          <a:blip r:embed="rId5"/>
+          <a:stretch>
+            <a:fillRect/>
+          </a:stretch>
+        </p:blipFill>
+        <p:spPr>
+          <a:xfrm>
+            <a:off x="4211441" y="3146975"/>
+            <a:ext cx="3296110" cy="5658640"/>
+          </a:xfrm>
+          <a:prstGeom prst="rect">
+            <a:avLst/>
+          </a:prstGeom>
         </p:spPr>
       </p:pic>
     </p:spTree>

</xml_diff>

<commit_message>
HR Database Design completed
</commit_message>
<xml_diff>
--- a/Modules/03-Data-Architect/projects/Project 1 - Human Resources Database Design/report/HR_Database_Design_Project_Arjun_Avalakki_Mohan.pptx
+++ b/Modules/03-Data-Architect/projects/Project 1 - Human Resources Database Design/report/HR_Database_Design_Project_Arjun_Avalakki_Mohan.pptx
@@ -319,18 +319,18 @@
   <pc:docChgLst>
     <pc:chgData name="ARJUN AVALAKKI MOHAN" userId="be4ab9aaf12c5868" providerId="LiveId" clId="{C81E60EF-EF5F-4B4B-A4E1-3178676F15CC}"/>
     <pc:docChg chg="undo custSel addSld delSld modSld">
-      <pc:chgData name="ARJUN AVALAKKI MOHAN" userId="be4ab9aaf12c5868" providerId="LiveId" clId="{C81E60EF-EF5F-4B4B-A4E1-3178676F15CC}" dt="2026-05-24T06:22:16.735" v="1033" actId="14100"/>
+      <pc:chgData name="ARJUN AVALAKKI MOHAN" userId="be4ab9aaf12c5868" providerId="LiveId" clId="{C81E60EF-EF5F-4B4B-A4E1-3178676F15CC}" dt="2026-05-25T04:35:03.466" v="1043" actId="14100"/>
       <pc:docMkLst>
         <pc:docMk/>
       </pc:docMkLst>
       <pc:sldChg chg="modSp mod">
-        <pc:chgData name="ARJUN AVALAKKI MOHAN" userId="be4ab9aaf12c5868" providerId="LiveId" clId="{C81E60EF-EF5F-4B4B-A4E1-3178676F15CC}" dt="2026-05-19T05:48:17.558" v="510" actId="20577"/>
+        <pc:chgData name="ARJUN AVALAKKI MOHAN" userId="be4ab9aaf12c5868" providerId="LiveId" clId="{C81E60EF-EF5F-4B4B-A4E1-3178676F15CC}" dt="2026-05-25T04:30:25.809" v="1037" actId="20577"/>
         <pc:sldMkLst>
           <pc:docMk/>
           <pc:sldMk cId="0" sldId="256"/>
         </pc:sldMkLst>
         <pc:spChg chg="mod">
-          <ac:chgData name="ARJUN AVALAKKI MOHAN" userId="be4ab9aaf12c5868" providerId="LiveId" clId="{C81E60EF-EF5F-4B4B-A4E1-3178676F15CC}" dt="2026-05-19T05:48:17.558" v="510" actId="20577"/>
+          <ac:chgData name="ARJUN AVALAKKI MOHAN" userId="be4ab9aaf12c5868" providerId="LiveId" clId="{C81E60EF-EF5F-4B4B-A4E1-3178676F15CC}" dt="2026-05-25T04:30:25.809" v="1037" actId="20577"/>
           <ac:spMkLst>
             <pc:docMk/>
             <pc:sldMk cId="0" sldId="256"/>
@@ -481,14 +481,6 @@
             <ac:picMk id="3" creationId="{0FA426DF-3EB2-5B29-14C6-AD8D9874DE10}"/>
           </ac:picMkLst>
         </pc:picChg>
-        <pc:picChg chg="add del mod">
-          <ac:chgData name="ARJUN AVALAKKI MOHAN" userId="be4ab9aaf12c5868" providerId="LiveId" clId="{C81E60EF-EF5F-4B4B-A4E1-3178676F15CC}" dt="2026-05-23T06:14:11.556" v="864" actId="478"/>
-          <ac:picMkLst>
-            <pc:docMk/>
-            <pc:sldMk cId="0" sldId="267"/>
-            <ac:picMk id="4" creationId="{A5722C49-878A-9ADD-0D36-BBD86256153F}"/>
-          </ac:picMkLst>
-        </pc:picChg>
       </pc:sldChg>
       <pc:sldChg chg="addSp delSp modSp mod modNotes">
         <pc:chgData name="ARJUN AVALAKKI MOHAN" userId="be4ab9aaf12c5868" providerId="LiveId" clId="{C81E60EF-EF5F-4B4B-A4E1-3178676F15CC}" dt="2026-05-23T06:18:07.555" v="896" actId="2085"/>
@@ -504,14 +496,6 @@
             <ac:spMk id="256" creationId="{00000000-0000-0000-0000-000000000000}"/>
           </ac:spMkLst>
         </pc:spChg>
-        <pc:picChg chg="add del mod">
-          <ac:chgData name="ARJUN AVALAKKI MOHAN" userId="be4ab9aaf12c5868" providerId="LiveId" clId="{C81E60EF-EF5F-4B4B-A4E1-3178676F15CC}" dt="2026-05-23T06:15:20.790" v="874" actId="478"/>
-          <ac:picMkLst>
-            <pc:docMk/>
-            <pc:sldMk cId="0" sldId="268"/>
-            <ac:picMk id="2" creationId="{83237B88-52C8-4925-B904-FB0AF33100D6}"/>
-          </ac:picMkLst>
-        </pc:picChg>
         <pc:picChg chg="add mod">
           <ac:chgData name="ARJUN AVALAKKI MOHAN" userId="be4ab9aaf12c5868" providerId="LiveId" clId="{C81E60EF-EF5F-4B4B-A4E1-3178676F15CC}" dt="2026-05-23T06:18:07.555" v="896" actId="2085"/>
           <ac:picMkLst>
@@ -522,7 +506,7 @@
         </pc:picChg>
       </pc:sldChg>
       <pc:sldChg chg="addSp delSp modSp mod modNotes">
-        <pc:chgData name="ARJUN AVALAKKI MOHAN" userId="be4ab9aaf12c5868" providerId="LiveId" clId="{C81E60EF-EF5F-4B4B-A4E1-3178676F15CC}" dt="2026-05-23T06:17:57.735" v="895" actId="2085"/>
+        <pc:chgData name="ARJUN AVALAKKI MOHAN" userId="be4ab9aaf12c5868" providerId="LiveId" clId="{C81E60EF-EF5F-4B4B-A4E1-3178676F15CC}" dt="2026-05-25T04:35:03.466" v="1043" actId="14100"/>
         <pc:sldMkLst>
           <pc:docMk/>
           <pc:sldMk cId="0" sldId="269"/>
@@ -535,20 +519,20 @@
             <ac:spMk id="263" creationId="{00000000-0000-0000-0000-000000000000}"/>
           </ac:spMkLst>
         </pc:spChg>
-        <pc:picChg chg="add mod">
-          <ac:chgData name="ARJUN AVALAKKI MOHAN" userId="be4ab9aaf12c5868" providerId="LiveId" clId="{C81E60EF-EF5F-4B4B-A4E1-3178676F15CC}" dt="2026-05-23T06:17:57.735" v="895" actId="2085"/>
+        <pc:picChg chg="add del mod">
+          <ac:chgData name="ARJUN AVALAKKI MOHAN" userId="be4ab9aaf12c5868" providerId="LiveId" clId="{C81E60EF-EF5F-4B4B-A4E1-3178676F15CC}" dt="2026-05-25T04:34:49.496" v="1038" actId="478"/>
           <ac:picMkLst>
             <pc:docMk/>
             <pc:sldMk cId="0" sldId="269"/>
             <ac:picMk id="3" creationId="{4FDF5F04-A16A-8719-A692-B9C7214704D4}"/>
           </ac:picMkLst>
         </pc:picChg>
-        <pc:picChg chg="add del mod">
-          <ac:chgData name="ARJUN AVALAKKI MOHAN" userId="be4ab9aaf12c5868" providerId="LiveId" clId="{C81E60EF-EF5F-4B4B-A4E1-3178676F15CC}" dt="2026-05-23T06:16:33.201" v="883" actId="478"/>
+        <pc:picChg chg="add mod">
+          <ac:chgData name="ARJUN AVALAKKI MOHAN" userId="be4ab9aaf12c5868" providerId="LiveId" clId="{C81E60EF-EF5F-4B4B-A4E1-3178676F15CC}" dt="2026-05-25T04:35:03.466" v="1043" actId="14100"/>
           <ac:picMkLst>
             <pc:docMk/>
             <pc:sldMk cId="0" sldId="269"/>
-            <ac:picMk id="4" creationId="{ECCD54A3-5A7D-7962-92AF-B50CC087C9F0}"/>
+            <ac:picMk id="4" creationId="{24632A6F-727E-0CA6-04D0-E39ACCE132AB}"/>
           </ac:picMkLst>
         </pc:picChg>
       </pc:sldChg>
@@ -565,14 +549,6 @@
           <pc:docMk/>
           <pc:sldMk cId="0" sldId="272"/>
         </pc:sldMkLst>
-        <pc:spChg chg="add del">
-          <ac:chgData name="ARJUN AVALAKKI MOHAN" userId="be4ab9aaf12c5868" providerId="LiveId" clId="{C81E60EF-EF5F-4B4B-A4E1-3178676F15CC}" dt="2026-05-23T06:49:21.873" v="910" actId="22"/>
-          <ac:spMkLst>
-            <pc:docMk/>
-            <pc:sldMk cId="0" sldId="272"/>
-            <ac:spMk id="8" creationId="{EF9905E1-C713-E4E1-2296-01DDFAD6042C}"/>
-          </ac:spMkLst>
-        </pc:spChg>
         <pc:spChg chg="add mod">
           <ac:chgData name="ARJUN AVALAKKI MOHAN" userId="be4ab9aaf12c5868" providerId="LiveId" clId="{C81E60EF-EF5F-4B4B-A4E1-3178676F15CC}" dt="2026-05-23T06:54:28.915" v="926" actId="14100"/>
           <ac:spMkLst>
@@ -589,14 +565,6 @@
             <ac:spMk id="282" creationId="{00000000-0000-0000-0000-000000000000}"/>
           </ac:spMkLst>
         </pc:spChg>
-        <pc:picChg chg="add del mod">
-          <ac:chgData name="ARJUN AVALAKKI MOHAN" userId="be4ab9aaf12c5868" providerId="LiveId" clId="{C81E60EF-EF5F-4B4B-A4E1-3178676F15CC}" dt="2026-05-23T06:48:19.247" v="898" actId="478"/>
-          <ac:picMkLst>
-            <pc:docMk/>
-            <pc:sldMk cId="0" sldId="272"/>
-            <ac:picMk id="3" creationId="{76232950-6D82-5068-3105-506D04C9CEFB}"/>
-          </ac:picMkLst>
-        </pc:picChg>
         <pc:picChg chg="add mod">
           <ac:chgData name="ARJUN AVALAKKI MOHAN" userId="be4ab9aaf12c5868" providerId="LiveId" clId="{C81E60EF-EF5F-4B4B-A4E1-3178676F15CC}" dt="2026-05-23T06:53:19.197" v="914" actId="1076"/>
           <ac:picMkLst>
@@ -605,36 +573,12 @@
             <ac:picMk id="4" creationId="{4ABB8DA1-DE2B-A470-FD35-BDB987176BFB}"/>
           </ac:picMkLst>
         </pc:picChg>
-        <pc:picChg chg="add del mod">
-          <ac:chgData name="ARJUN AVALAKKI MOHAN" userId="be4ab9aaf12c5868" providerId="LiveId" clId="{C81E60EF-EF5F-4B4B-A4E1-3178676F15CC}" dt="2026-05-23T06:48:20.079" v="899" actId="478"/>
-          <ac:picMkLst>
-            <pc:docMk/>
-            <pc:sldMk cId="0" sldId="272"/>
-            <ac:picMk id="5" creationId="{28FE4F40-9295-B4A4-C7A6-585514873CBB}"/>
-          </ac:picMkLst>
-        </pc:picChg>
-        <pc:picChg chg="add del mod">
-          <ac:chgData name="ARJUN AVALAKKI MOHAN" userId="be4ab9aaf12c5868" providerId="LiveId" clId="{C81E60EF-EF5F-4B4B-A4E1-3178676F15CC}" dt="2026-05-23T06:48:51.392" v="908" actId="478"/>
-          <ac:picMkLst>
-            <pc:docMk/>
-            <pc:sldMk cId="0" sldId="272"/>
-            <ac:picMk id="7" creationId="{900B74AF-50A8-EDCD-6B4E-3FA9662EE864}"/>
-          </ac:picMkLst>
-        </pc:picChg>
         <pc:picChg chg="add mod">
           <ac:chgData name="ARJUN AVALAKKI MOHAN" userId="be4ab9aaf12c5868" providerId="LiveId" clId="{C81E60EF-EF5F-4B4B-A4E1-3178676F15CC}" dt="2026-05-23T06:53:21.538" v="915" actId="1076"/>
           <ac:picMkLst>
             <pc:docMk/>
             <pc:sldMk cId="0" sldId="272"/>
             <ac:picMk id="10" creationId="{49044BF0-8CAC-97D0-42E8-72488806D257}"/>
-          </ac:picMkLst>
-        </pc:picChg>
-        <pc:picChg chg="del">
-          <ac:chgData name="ARJUN AVALAKKI MOHAN" userId="be4ab9aaf12c5868" providerId="LiveId" clId="{C81E60EF-EF5F-4B4B-A4E1-3178676F15CC}" dt="2026-05-23T04:40:01.333" v="834" actId="478"/>
-          <ac:picMkLst>
-            <pc:docMk/>
-            <pc:sldMk cId="0" sldId="272"/>
-            <ac:picMk id="283" creationId="{00000000-0000-0000-0000-000000000000}"/>
           </ac:picMkLst>
         </pc:picChg>
       </pc:sldChg>
@@ -27938,7 +27882,7 @@
                   <a:srgbClr val="FFFFFF"/>
                 </a:solidFill>
               </a:rPr>
-              <a:t>[Arjun Avalakki Mohan &amp; 17/05/2026]</a:t>
+              <a:t>[Arjun Avalakki Mohan &amp; 25/05/2026]</a:t>
             </a:r>
             <a:endParaRPr sz="2500" dirty="0">
               <a:solidFill>
@@ -29256,10 +29200,10 @@
       </p:sp>
       <p:pic>
         <p:nvPicPr>
-          <p:cNvPr id="3" name="Picture 2">
+          <p:cNvPr id="4" name="Picture 3">
             <a:extLst>
               <a:ext uri="{FF2B5EF4-FFF2-40B4-BE49-F238E27FC236}">
-                <a16:creationId xmlns:a16="http://schemas.microsoft.com/office/drawing/2014/main" id="{4FDF5F04-A16A-8719-A692-B9C7214704D4}"/>
+                <a16:creationId xmlns:a16="http://schemas.microsoft.com/office/drawing/2014/main" id="{24632A6F-727E-0CA6-04D0-E39ACCE132AB}"/>
               </a:ext>
             </a:extLst>
           </p:cNvPr>
@@ -29276,15 +29220,12 @@
         </p:blipFill>
         <p:spPr>
           <a:xfrm>
-            <a:off x="264900" y="5029200"/>
-            <a:ext cx="7242600" cy="4439920"/>
+            <a:off x="264900" y="5178037"/>
+            <a:ext cx="7242600" cy="4101887"/>
           </a:xfrm>
           <a:prstGeom prst="rect">
             <a:avLst/>
           </a:prstGeom>
-          <a:ln>
-            <a:noFill/>
-          </a:ln>
         </p:spPr>
       </p:pic>
     </p:spTree>

</xml_diff>

<commit_message>
Included Grant and Revoke SQL Script
</commit_message>
<xml_diff>
--- a/Modules/03-Data-Architect/projects/Project 1 - Human Resources Database Design/report/HR_Database_Design_Project_Arjun_Avalakki_Mohan.pptx
+++ b/Modules/03-Data-Architect/projects/Project 1 - Human Resources Database Design/report/HR_Database_Design_Project_Arjun_Avalakki_Mohan.pptx
@@ -309,7 +309,7 @@
 <file path=ppt/revisionInfo.xml><?xml version="1.0" encoding="utf-8"?>
 <p1510:revInfo xmlns:a="http://schemas.openxmlformats.org/drawingml/2006/main" xmlns:r="http://schemas.openxmlformats.org/officeDocument/2006/relationships" xmlns:p1510="http://schemas.microsoft.com/office/powerpoint/2015/10/main">
   <p1510:revLst>
-    <p1510:client id="{CEECDE29-5A9E-4E44-A6A5-88C1A3F6F982}" v="8" dt="2026-05-24T06:08:02.044"/>
+    <p1510:client id="{CEECDE29-5A9E-4E44-A6A5-88C1A3F6F982}" v="18" dt="2026-05-26T04:40:26.300"/>
   </p1510:revLst>
 </p1510:revInfo>
 </file>
@@ -319,7 +319,7 @@
   <pc:docChgLst>
     <pc:chgData name="ARJUN AVALAKKI MOHAN" userId="be4ab9aaf12c5868" providerId="LiveId" clId="{C81E60EF-EF5F-4B4B-A4E1-3178676F15CC}"/>
     <pc:docChg chg="undo custSel addSld delSld modSld">
-      <pc:chgData name="ARJUN AVALAKKI MOHAN" userId="be4ab9aaf12c5868" providerId="LiveId" clId="{C81E60EF-EF5F-4B4B-A4E1-3178676F15CC}" dt="2026-05-25T04:35:03.466" v="1043" actId="14100"/>
+      <pc:chgData name="ARJUN AVALAKKI MOHAN" userId="be4ab9aaf12c5868" providerId="LiveId" clId="{C81E60EF-EF5F-4B4B-A4E1-3178676F15CC}" dt="2026-05-26T04:42:54.778" v="1124" actId="1076"/>
       <pc:docMkLst>
         <pc:docMk/>
       </pc:docMkLst>
@@ -596,28 +596,12 @@
             <ac:spMk id="289" creationId="{00000000-0000-0000-0000-000000000000}"/>
           </ac:spMkLst>
         </pc:spChg>
-        <pc:picChg chg="add del mod">
-          <ac:chgData name="ARJUN AVALAKKI MOHAN" userId="be4ab9aaf12c5868" providerId="LiveId" clId="{C81E60EF-EF5F-4B4B-A4E1-3178676F15CC}" dt="2026-05-24T06:22:07.148" v="1029" actId="478"/>
-          <ac:picMkLst>
-            <pc:docMk/>
-            <pc:sldMk cId="0" sldId="273"/>
-            <ac:picMk id="3" creationId="{EA0E80B0-48C1-3292-CFC4-6DB6C9AE6DFC}"/>
-          </ac:picMkLst>
-        </pc:picChg>
         <pc:picChg chg="add mod">
           <ac:chgData name="ARJUN AVALAKKI MOHAN" userId="be4ab9aaf12c5868" providerId="LiveId" clId="{C81E60EF-EF5F-4B4B-A4E1-3178676F15CC}" dt="2026-05-24T06:22:16.735" v="1033" actId="14100"/>
           <ac:picMkLst>
             <pc:docMk/>
             <pc:sldMk cId="0" sldId="273"/>
             <ac:picMk id="4" creationId="{E7D7F0C1-09C7-B9D4-ADCE-9AB087EE1367}"/>
-          </ac:picMkLst>
-        </pc:picChg>
-        <pc:picChg chg="del">
-          <ac:chgData name="ARJUN AVALAKKI MOHAN" userId="be4ab9aaf12c5868" providerId="LiveId" clId="{C81E60EF-EF5F-4B4B-A4E1-3178676F15CC}" dt="2026-05-24T05:45:46.602" v="949" actId="478"/>
-          <ac:picMkLst>
-            <pc:docMk/>
-            <pc:sldMk cId="0" sldId="273"/>
-            <ac:picMk id="290" creationId="{00000000-0000-0000-0000-000000000000}"/>
           </ac:picMkLst>
         </pc:picChg>
       </pc:sldChg>
@@ -643,14 +627,6 @@
             <ac:picMk id="3" creationId="{9C254158-8C0A-2798-C371-0E517A405794}"/>
           </ac:picMkLst>
         </pc:picChg>
-        <pc:picChg chg="del">
-          <ac:chgData name="ARJUN AVALAKKI MOHAN" userId="be4ab9aaf12c5868" providerId="LiveId" clId="{C81E60EF-EF5F-4B4B-A4E1-3178676F15CC}" dt="2026-05-24T05:53:30.469" v="960" actId="478"/>
-          <ac:picMkLst>
-            <pc:docMk/>
-            <pc:sldMk cId="0" sldId="274"/>
-            <ac:picMk id="297" creationId="{00000000-0000-0000-0000-000000000000}"/>
-          </ac:picMkLst>
-        </pc:picChg>
       </pc:sldChg>
       <pc:sldChg chg="addSp delSp modSp mod modNotes">
         <pc:chgData name="ARJUN AVALAKKI MOHAN" userId="be4ab9aaf12c5868" providerId="LiveId" clId="{C81E60EF-EF5F-4B4B-A4E1-3178676F15CC}" dt="2026-05-24T05:55:40.958" v="973" actId="1076"/>
@@ -672,14 +648,6 @@
             <pc:docMk/>
             <pc:sldMk cId="0" sldId="275"/>
             <ac:picMk id="3" creationId="{26EEDA14-9EDB-090D-C1DB-8484BDC7DB29}"/>
-          </ac:picMkLst>
-        </pc:picChg>
-        <pc:picChg chg="del">
-          <ac:chgData name="ARJUN AVALAKKI MOHAN" userId="be4ab9aaf12c5868" providerId="LiveId" clId="{C81E60EF-EF5F-4B4B-A4E1-3178676F15CC}" dt="2026-05-24T05:55:17.560" v="964" actId="478"/>
-          <ac:picMkLst>
-            <pc:docMk/>
-            <pc:sldMk cId="0" sldId="275"/>
-            <ac:picMk id="304" creationId="{00000000-0000-0000-0000-000000000000}"/>
           </ac:picMkLst>
         </pc:picChg>
       </pc:sldChg>
@@ -705,14 +673,6 @@
             <ac:picMk id="3" creationId="{BADAC383-CE7A-5023-827F-1EEAFC70C372}"/>
           </ac:picMkLst>
         </pc:picChg>
-        <pc:picChg chg="del">
-          <ac:chgData name="ARJUN AVALAKKI MOHAN" userId="be4ab9aaf12c5868" providerId="LiveId" clId="{C81E60EF-EF5F-4B4B-A4E1-3178676F15CC}" dt="2026-05-24T05:59:19.569" v="974" actId="478"/>
-          <ac:picMkLst>
-            <pc:docMk/>
-            <pc:sldMk cId="0" sldId="276"/>
-            <ac:picMk id="311" creationId="{00000000-0000-0000-0000-000000000000}"/>
-          </ac:picMkLst>
-        </pc:picChg>
       </pc:sldChg>
       <pc:sldChg chg="addSp delSp modSp mod modNotes">
         <pc:chgData name="ARJUN AVALAKKI MOHAN" userId="be4ab9aaf12c5868" providerId="LiveId" clId="{C81E60EF-EF5F-4B4B-A4E1-3178676F15CC}" dt="2026-05-24T06:03:31.527" v="1002" actId="14100"/>
@@ -734,14 +694,6 @@
             <pc:docMk/>
             <pc:sldMk cId="0" sldId="277"/>
             <ac:picMk id="3" creationId="{C9927469-411D-D575-839D-84C34A8510E9}"/>
-          </ac:picMkLst>
-        </pc:picChg>
-        <pc:picChg chg="del">
-          <ac:chgData name="ARJUN AVALAKKI MOHAN" userId="be4ab9aaf12c5868" providerId="LiveId" clId="{C81E60EF-EF5F-4B4B-A4E1-3178676F15CC}" dt="2026-05-24T06:02:59.447" v="985" actId="478"/>
-          <ac:picMkLst>
-            <pc:docMk/>
-            <pc:sldMk cId="0" sldId="277"/>
-            <ac:picMk id="318" creationId="{00000000-0000-0000-0000-000000000000}"/>
           </ac:picMkLst>
         </pc:picChg>
       </pc:sldChg>
@@ -767,23 +719,15 @@
             <ac:picMk id="3" creationId="{ACFCD5A7-D41D-6C52-2B9C-D691A8AA9C0D}"/>
           </ac:picMkLst>
         </pc:picChg>
-        <pc:picChg chg="del">
-          <ac:chgData name="ARJUN AVALAKKI MOHAN" userId="be4ab9aaf12c5868" providerId="LiveId" clId="{C81E60EF-EF5F-4B4B-A4E1-3178676F15CC}" dt="2026-05-24T06:05:21.764" v="1003" actId="478"/>
-          <ac:picMkLst>
-            <pc:docMk/>
-            <pc:sldMk cId="0" sldId="278"/>
-            <ac:picMk id="325" creationId="{00000000-0000-0000-0000-000000000000}"/>
-          </ac:picMkLst>
-        </pc:picChg>
       </pc:sldChg>
       <pc:sldChg chg="modSp mod modNotes">
-        <pc:chgData name="ARJUN AVALAKKI MOHAN" userId="be4ab9aaf12c5868" providerId="LiveId" clId="{C81E60EF-EF5F-4B4B-A4E1-3178676F15CC}" dt="2026-05-24T06:08:54.692" v="1027" actId="14100"/>
+        <pc:chgData name="ARJUN AVALAKKI MOHAN" userId="be4ab9aaf12c5868" providerId="LiveId" clId="{C81E60EF-EF5F-4B4B-A4E1-3178676F15CC}" dt="2026-05-26T04:42:54.778" v="1124" actId="1076"/>
         <pc:sldMkLst>
           <pc:docMk/>
           <pc:sldMk cId="0" sldId="279"/>
         </pc:sldMkLst>
         <pc:spChg chg="mod">
-          <ac:chgData name="ARJUN AVALAKKI MOHAN" userId="be4ab9aaf12c5868" providerId="LiveId" clId="{C81E60EF-EF5F-4B4B-A4E1-3178676F15CC}" dt="2026-05-24T06:08:54.692" v="1027" actId="14100"/>
+          <ac:chgData name="ARJUN AVALAKKI MOHAN" userId="be4ab9aaf12c5868" providerId="LiveId" clId="{C81E60EF-EF5F-4B4B-A4E1-3178676F15CC}" dt="2026-05-26T04:42:54.778" v="1124" actId="1076"/>
           <ac:spMkLst>
             <pc:docMk/>
             <pc:sldMk cId="0" sldId="279"/>
@@ -828,44 +772,12 @@
             <ac:spMk id="11" creationId="{97E99462-E313-08C0-92C2-6581D6E45DD1}"/>
           </ac:spMkLst>
         </pc:spChg>
-        <pc:picChg chg="add del mod">
-          <ac:chgData name="ARJUN AVALAKKI MOHAN" userId="be4ab9aaf12c5868" providerId="LiveId" clId="{C81E60EF-EF5F-4B4B-A4E1-3178676F15CC}" dt="2026-05-24T05:37:17.572" v="935" actId="478"/>
-          <ac:picMkLst>
-            <pc:docMk/>
-            <pc:sldMk cId="484767743" sldId="288"/>
-            <ac:picMk id="3" creationId="{C7EEF720-796D-98E9-C6CF-1B68DA78435F}"/>
-          </ac:picMkLst>
-        </pc:picChg>
-        <pc:picChg chg="del">
-          <ac:chgData name="ARJUN AVALAKKI MOHAN" userId="be4ab9aaf12c5868" providerId="LiveId" clId="{C81E60EF-EF5F-4B4B-A4E1-3178676F15CC}" dt="2026-05-24T05:29:58.375" v="928" actId="478"/>
-          <ac:picMkLst>
-            <pc:docMk/>
-            <pc:sldMk cId="484767743" sldId="288"/>
-            <ac:picMk id="4" creationId="{CC73533D-2F9C-7644-C31A-DD9AB972C2D8}"/>
-          </ac:picMkLst>
-        </pc:picChg>
-        <pc:picChg chg="add del mod">
-          <ac:chgData name="ARJUN AVALAKKI MOHAN" userId="be4ab9aaf12c5868" providerId="LiveId" clId="{C81E60EF-EF5F-4B4B-A4E1-3178676F15CC}" dt="2026-05-24T05:38:58.308" v="940" actId="478"/>
-          <ac:picMkLst>
-            <pc:docMk/>
-            <pc:sldMk cId="484767743" sldId="288"/>
-            <ac:picMk id="6" creationId="{6037F583-1076-4A43-642A-3448DBE7BF97}"/>
-          </ac:picMkLst>
-        </pc:picChg>
         <pc:picChg chg="add mod">
           <ac:chgData name="ARJUN AVALAKKI MOHAN" userId="be4ab9aaf12c5868" providerId="LiveId" clId="{C81E60EF-EF5F-4B4B-A4E1-3178676F15CC}" dt="2026-05-24T05:39:06.059" v="944" actId="14100"/>
           <ac:picMkLst>
             <pc:docMk/>
             <pc:sldMk cId="484767743" sldId="288"/>
             <ac:picMk id="8" creationId="{7506F691-7B00-3236-49B2-A466B351F89B}"/>
-          </ac:picMkLst>
-        </pc:picChg>
-        <pc:picChg chg="del">
-          <ac:chgData name="ARJUN AVALAKKI MOHAN" userId="be4ab9aaf12c5868" providerId="LiveId" clId="{C81E60EF-EF5F-4B4B-A4E1-3178676F15CC}" dt="2026-05-24T05:29:59.320" v="929" actId="478"/>
-          <ac:picMkLst>
-            <pc:docMk/>
-            <pc:sldMk cId="484767743" sldId="288"/>
-            <ac:picMk id="10" creationId="{691005A1-7CCE-407F-FBB7-4EED88154932}"/>
           </ac:picMkLst>
         </pc:picChg>
       </pc:sldChg>
@@ -33806,10 +33718,10 @@
               <a:buNone/>
             </a:pPr>
             <a:r>
-              <a:rPr lang="en"/>
+              <a:rPr lang="en" dirty="0"/>
               <a:t>CRUD</a:t>
             </a:r>
-            <a:endParaRPr/>
+            <a:endParaRPr dirty="0"/>
           </a:p>
         </p:txBody>
       </p:sp>
@@ -33825,8 +33737,8 @@
         </p:nvSpPr>
         <p:spPr>
           <a:xfrm>
-            <a:off x="264950" y="2253724"/>
-            <a:ext cx="7242600" cy="4035865"/>
+            <a:off x="264945" y="1964221"/>
+            <a:ext cx="7242600" cy="7223908"/>
           </a:xfrm>
           <a:prstGeom prst="rect">
             <a:avLst/>
@@ -33867,50 +33779,459 @@
           </a:p>
           <a:p>
             <a:pPr lvl="0" indent="0">
-              <a:spcBef>
-                <a:spcPts val="1600"/>
-              </a:spcBef>
               <a:buNone/>
             </a:pPr>
             <a:r>
-              <a:rPr lang="en-GB" sz="1400" dirty="0"/>
-              <a:t>- I would apply table security by creating database roles and granting salary table access only to authorized users such as HR or Payroll teams. </a:t>
-            </a:r>
-          </a:p>
-          <a:p>
-            <a:pPr lvl="0" indent="0">
-              <a:spcBef>
-                <a:spcPts val="1600"/>
-              </a:spcBef>
-              <a:buNone/>
-            </a:pPr>
-            <a:r>
-              <a:rPr lang="en-GB" sz="1400" dirty="0"/>
-              <a:t>- Regular users would be denied direct access to the </a:t>
+              <a:rPr lang="en-US" sz="1400" dirty="0">
+                <a:sym typeface="Open Sans"/>
+              </a:rPr>
+              <a:t>I would apply table-level security by creating separate database roles for normal users and HR or management users. Normal users should only have read-only access to non-sensitive tables such as employee, department, job, location, </a:t>
             </a:r>
             <a:r>
-              <a:rPr lang="en-GB" sz="1400" dirty="0" err="1"/>
+              <a:rPr lang="en-US" sz="1400" dirty="0" err="1">
+                <a:sym typeface="Open Sans"/>
+              </a:rPr>
+              <a:t>employee_job_history</a:t>
+            </a:r>
+            <a:r>
+              <a:rPr lang="en-US" sz="1400" dirty="0">
+                <a:sym typeface="Open Sans"/>
+              </a:rPr>
+              <a:t>, and </a:t>
+            </a:r>
+            <a:r>
+              <a:rPr lang="en-US" sz="1400" dirty="0" err="1">
+                <a:sym typeface="Open Sans"/>
+              </a:rPr>
+              <a:t>education_level</a:t>
+            </a:r>
+            <a:r>
+              <a:rPr lang="en-US" sz="1400" dirty="0">
+                <a:sym typeface="Open Sans"/>
+              </a:rPr>
+              <a:t>. They should not have access to the </a:t>
+            </a:r>
+            <a:r>
+              <a:rPr lang="en-US" sz="1400" dirty="0" err="1">
+                <a:sym typeface="Open Sans"/>
+              </a:rPr>
               <a:t>employee_salary</a:t>
             </a:r>
             <a:r>
-              <a:rPr lang="en-GB" sz="1400" dirty="0"/>
-              <a:t> table using REVOKE statements, while approved users would receive SELECT, INSERT, or UPDATE permissions as required. </a:t>
+              <a:rPr lang="en-US" sz="1400" dirty="0">
+                <a:sym typeface="Open Sans"/>
+              </a:rPr>
+              <a:t> table.</a:t>
             </a:r>
           </a:p>
           <a:p>
             <a:pPr lvl="0" indent="0">
-              <a:spcBef>
-                <a:spcPts val="1600"/>
+              <a:buNone/>
+            </a:pPr>
+            <a:endParaRPr lang="en-US" sz="1400" dirty="0">
+              <a:sym typeface="Open Sans"/>
+            </a:endParaRPr>
+          </a:p>
+          <a:p>
+            <a:pPr lvl="1" indent="0">
+              <a:spcBef>
+                <a:spcPts val="0"/>
               </a:spcBef>
               <a:buNone/>
             </a:pPr>
             <a:r>
-              <a:rPr lang="en-GB" sz="1400" dirty="0"/>
-              <a:t>- Additional security could include views to hide sensitive salary information and auditing to track who accesses salary data.</a:t>
+              <a:rPr lang="en-US" sz="1400" b="1" u="sng" dirty="0">
+                <a:sym typeface="Open Sans"/>
+              </a:rPr>
+              <a:t>Example SQL:</a:t>
             </a:r>
-            <a:endParaRPr sz="1400" dirty="0">
+          </a:p>
+          <a:p>
+            <a:pPr lvl="1" indent="0">
+              <a:spcBef>
+                <a:spcPts val="0"/>
+              </a:spcBef>
+              <a:buNone/>
+            </a:pPr>
+            <a:r>
+              <a:rPr lang="en-US" sz="1400" i="1" dirty="0">
+                <a:solidFill>
+                  <a:srgbClr val="FF0000"/>
+                </a:solidFill>
+                <a:sym typeface="Open Sans"/>
+              </a:rPr>
+              <a:t>CREATE ROLE </a:t>
+            </a:r>
+            <a:r>
+              <a:rPr lang="en-US" sz="1400" i="1" dirty="0" err="1">
+                <a:solidFill>
+                  <a:srgbClr val="FF0000"/>
+                </a:solidFill>
+                <a:sym typeface="Open Sans"/>
+              </a:rPr>
+              <a:t>readonly_user</a:t>
+            </a:r>
+            <a:r>
+              <a:rPr lang="en-US" sz="1400" i="1" dirty="0">
+                <a:solidFill>
+                  <a:srgbClr val="FF0000"/>
+                </a:solidFill>
+                <a:sym typeface="Open Sans"/>
+              </a:rPr>
+              <a:t>;</a:t>
+            </a:r>
+          </a:p>
+          <a:p>
+            <a:pPr lvl="1" indent="0">
+              <a:spcBef>
+                <a:spcPts val="0"/>
+              </a:spcBef>
+              <a:buNone/>
+            </a:pPr>
+            <a:r>
+              <a:rPr lang="en-US" sz="1400" i="1" dirty="0">
+                <a:solidFill>
+                  <a:srgbClr val="FF0000"/>
+                </a:solidFill>
+                <a:sym typeface="Open Sans"/>
+              </a:rPr>
+              <a:t>GRANT SELECT ON employee, department, job, location, </a:t>
+            </a:r>
+            <a:r>
+              <a:rPr lang="en-US" sz="1400" i="1" dirty="0" err="1">
+                <a:solidFill>
+                  <a:srgbClr val="FF0000"/>
+                </a:solidFill>
+                <a:sym typeface="Open Sans"/>
+              </a:rPr>
+              <a:t>employee_job_history</a:t>
+            </a:r>
+            <a:r>
+              <a:rPr lang="en-US" sz="1400" i="1" dirty="0">
+                <a:solidFill>
+                  <a:srgbClr val="FF0000"/>
+                </a:solidFill>
+                <a:sym typeface="Open Sans"/>
+              </a:rPr>
+              <a:t>, </a:t>
+            </a:r>
+            <a:r>
+              <a:rPr lang="en-US" sz="1400" i="1" dirty="0" err="1">
+                <a:solidFill>
+                  <a:srgbClr val="FF0000"/>
+                </a:solidFill>
+                <a:sym typeface="Open Sans"/>
+              </a:rPr>
+              <a:t>education_level</a:t>
+            </a:r>
+            <a:r>
+              <a:rPr lang="en-US" sz="1400" i="1" dirty="0">
+                <a:solidFill>
+                  <a:srgbClr val="FF0000"/>
+                </a:solidFill>
+                <a:sym typeface="Open Sans"/>
+              </a:rPr>
+              <a:t> TO </a:t>
+            </a:r>
+            <a:r>
+              <a:rPr lang="en-US" sz="1400" i="1" dirty="0" err="1">
+                <a:solidFill>
+                  <a:srgbClr val="FF0000"/>
+                </a:solidFill>
+                <a:sym typeface="Open Sans"/>
+              </a:rPr>
+              <a:t>readonly_user</a:t>
+            </a:r>
+            <a:r>
+              <a:rPr lang="en-US" sz="1400" i="1" dirty="0">
+                <a:solidFill>
+                  <a:srgbClr val="FF0000"/>
+                </a:solidFill>
+                <a:sym typeface="Open Sans"/>
+              </a:rPr>
+              <a:t>;</a:t>
+            </a:r>
+          </a:p>
+          <a:p>
+            <a:pPr lvl="1" indent="0">
+              <a:spcBef>
+                <a:spcPts val="0"/>
+              </a:spcBef>
+              <a:buNone/>
+            </a:pPr>
+            <a:r>
+              <a:rPr lang="en-US" sz="1400" i="1" dirty="0">
+                <a:solidFill>
+                  <a:srgbClr val="FF0000"/>
+                </a:solidFill>
+                <a:sym typeface="Open Sans"/>
+              </a:rPr>
+              <a:t>REVOKE ALL ON </a:t>
+            </a:r>
+            <a:r>
+              <a:rPr lang="en-US" sz="1400" i="1" dirty="0" err="1">
+                <a:solidFill>
+                  <a:srgbClr val="FF0000"/>
+                </a:solidFill>
+                <a:sym typeface="Open Sans"/>
+              </a:rPr>
+              <a:t>employee_salary</a:t>
+            </a:r>
+            <a:r>
+              <a:rPr lang="en-US" sz="1400" i="1" dirty="0">
+                <a:solidFill>
+                  <a:srgbClr val="FF0000"/>
+                </a:solidFill>
+                <a:sym typeface="Open Sans"/>
+              </a:rPr>
+              <a:t> FROM </a:t>
+            </a:r>
+            <a:r>
+              <a:rPr lang="en-US" sz="1400" i="1" dirty="0" err="1">
+                <a:solidFill>
+                  <a:srgbClr val="FF0000"/>
+                </a:solidFill>
+                <a:sym typeface="Open Sans"/>
+              </a:rPr>
+              <a:t>readonly_user</a:t>
+            </a:r>
+            <a:r>
+              <a:rPr lang="en-US" sz="1400" i="1" dirty="0">
+                <a:solidFill>
+                  <a:srgbClr val="FF0000"/>
+                </a:solidFill>
+                <a:sym typeface="Open Sans"/>
+              </a:rPr>
+              <a:t>;</a:t>
+            </a:r>
+          </a:p>
+          <a:p>
+            <a:pPr lvl="1" indent="0">
+              <a:spcBef>
+                <a:spcPts val="0"/>
+              </a:spcBef>
+              <a:buNone/>
+            </a:pPr>
+            <a:endParaRPr lang="en-US" sz="1400" dirty="0">
               <a:sym typeface="Open Sans"/>
             </a:endParaRPr>
+          </a:p>
+          <a:p>
+            <a:pPr indent="0">
+              <a:buNone/>
+            </a:pPr>
+            <a:r>
+              <a:rPr lang="en-US" sz="1400" dirty="0">
+                <a:sym typeface="Open Sans"/>
+              </a:rPr>
+              <a:t>For HR and management users, I would create a separate role with access to salary information.</a:t>
+            </a:r>
+          </a:p>
+          <a:p>
+            <a:pPr lvl="1" indent="0">
+              <a:spcBef>
+                <a:spcPts val="0"/>
+              </a:spcBef>
+              <a:buNone/>
+            </a:pPr>
+            <a:endParaRPr lang="en-US" sz="1400" dirty="0">
+              <a:sym typeface="Open Sans"/>
+            </a:endParaRPr>
+          </a:p>
+          <a:p>
+            <a:pPr lvl="1" indent="0">
+              <a:spcBef>
+                <a:spcPts val="0"/>
+              </a:spcBef>
+              <a:buNone/>
+            </a:pPr>
+            <a:r>
+              <a:rPr lang="en-US" sz="1400" b="1" u="sng" dirty="0">
+                <a:sym typeface="Open Sans"/>
+              </a:rPr>
+              <a:t>Example SQL:</a:t>
+            </a:r>
+          </a:p>
+          <a:p>
+            <a:pPr lvl="1" indent="0">
+              <a:spcBef>
+                <a:spcPts val="0"/>
+              </a:spcBef>
+              <a:buNone/>
+            </a:pPr>
+            <a:r>
+              <a:rPr lang="en-US" sz="1400" i="1" dirty="0">
+                <a:solidFill>
+                  <a:srgbClr val="FF0000"/>
+                </a:solidFill>
+                <a:sym typeface="Open Sans"/>
+              </a:rPr>
+              <a:t>CREATE ROLE </a:t>
+            </a:r>
+            <a:r>
+              <a:rPr lang="en-US" sz="1400" i="1" dirty="0" err="1">
+                <a:solidFill>
+                  <a:srgbClr val="FF0000"/>
+                </a:solidFill>
+                <a:sym typeface="Open Sans"/>
+              </a:rPr>
+              <a:t>hr_manager</a:t>
+            </a:r>
+            <a:r>
+              <a:rPr lang="en-US" sz="1400" i="1" dirty="0">
+                <a:solidFill>
+                  <a:srgbClr val="FF0000"/>
+                </a:solidFill>
+                <a:sym typeface="Open Sans"/>
+              </a:rPr>
+              <a:t>;</a:t>
+            </a:r>
+          </a:p>
+          <a:p>
+            <a:pPr lvl="1" indent="0">
+              <a:spcBef>
+                <a:spcPts val="0"/>
+              </a:spcBef>
+              <a:buNone/>
+            </a:pPr>
+            <a:r>
+              <a:rPr lang="en-US" sz="1400" i="1" dirty="0">
+                <a:solidFill>
+                  <a:srgbClr val="FF0000"/>
+                </a:solidFill>
+                <a:sym typeface="Open Sans"/>
+              </a:rPr>
+              <a:t>GRANT SELECT, INSERT, UPDATE ON </a:t>
+            </a:r>
+            <a:r>
+              <a:rPr lang="en-US" sz="1400" i="1" dirty="0" err="1">
+                <a:solidFill>
+                  <a:srgbClr val="FF0000"/>
+                </a:solidFill>
+                <a:sym typeface="Open Sans"/>
+              </a:rPr>
+              <a:t>employee_salary</a:t>
+            </a:r>
+            <a:r>
+              <a:rPr lang="en-US" sz="1400" i="1" dirty="0">
+                <a:solidFill>
+                  <a:srgbClr val="FF0000"/>
+                </a:solidFill>
+                <a:sym typeface="Open Sans"/>
+              </a:rPr>
+              <a:t> TO </a:t>
+            </a:r>
+            <a:r>
+              <a:rPr lang="en-US" sz="1400" i="1" dirty="0" err="1">
+                <a:solidFill>
+                  <a:srgbClr val="FF0000"/>
+                </a:solidFill>
+                <a:sym typeface="Open Sans"/>
+              </a:rPr>
+              <a:t>hr_manager</a:t>
+            </a:r>
+            <a:r>
+              <a:rPr lang="en-US" sz="1400" i="1" dirty="0">
+                <a:solidFill>
+                  <a:srgbClr val="FF0000"/>
+                </a:solidFill>
+                <a:sym typeface="Open Sans"/>
+              </a:rPr>
+              <a:t>;</a:t>
+            </a:r>
+          </a:p>
+          <a:p>
+            <a:pPr lvl="1" indent="0">
+              <a:spcBef>
+                <a:spcPts val="0"/>
+              </a:spcBef>
+              <a:buNone/>
+            </a:pPr>
+            <a:r>
+              <a:rPr lang="en-US" sz="1400" i="1" dirty="0">
+                <a:solidFill>
+                  <a:srgbClr val="FF0000"/>
+                </a:solidFill>
+                <a:sym typeface="Open Sans"/>
+              </a:rPr>
+              <a:t>GRANT SELECT, INSERT, UPDATE ON employee, department, job, location, </a:t>
+            </a:r>
+            <a:r>
+              <a:rPr lang="en-US" sz="1400" i="1" dirty="0" err="1">
+                <a:solidFill>
+                  <a:srgbClr val="FF0000"/>
+                </a:solidFill>
+                <a:sym typeface="Open Sans"/>
+              </a:rPr>
+              <a:t>employee_job_history</a:t>
+            </a:r>
+            <a:r>
+              <a:rPr lang="en-US" sz="1400" i="1" dirty="0">
+                <a:solidFill>
+                  <a:srgbClr val="FF0000"/>
+                </a:solidFill>
+                <a:sym typeface="Open Sans"/>
+              </a:rPr>
+              <a:t>, </a:t>
+            </a:r>
+            <a:r>
+              <a:rPr lang="en-US" sz="1400" i="1" dirty="0" err="1">
+                <a:solidFill>
+                  <a:srgbClr val="FF0000"/>
+                </a:solidFill>
+                <a:sym typeface="Open Sans"/>
+              </a:rPr>
+              <a:t>education_level</a:t>
+            </a:r>
+            <a:r>
+              <a:rPr lang="en-US" sz="1400" i="1" dirty="0">
+                <a:solidFill>
+                  <a:srgbClr val="FF0000"/>
+                </a:solidFill>
+                <a:sym typeface="Open Sans"/>
+              </a:rPr>
+              <a:t> TO </a:t>
+            </a:r>
+            <a:r>
+              <a:rPr lang="en-US" sz="1400" i="1" dirty="0" err="1">
+                <a:solidFill>
+                  <a:srgbClr val="FF0000"/>
+                </a:solidFill>
+                <a:sym typeface="Open Sans"/>
+              </a:rPr>
+              <a:t>hr_manager</a:t>
+            </a:r>
+            <a:r>
+              <a:rPr lang="en-US" sz="1400" i="1" dirty="0">
+                <a:solidFill>
+                  <a:srgbClr val="FF0000"/>
+                </a:solidFill>
+                <a:sym typeface="Open Sans"/>
+              </a:rPr>
+              <a:t>;</a:t>
+            </a:r>
+          </a:p>
+          <a:p>
+            <a:pPr lvl="0" indent="0">
+              <a:buNone/>
+            </a:pPr>
+            <a:endParaRPr lang="en-US" sz="1400" i="1" dirty="0">
+              <a:solidFill>
+                <a:srgbClr val="FF0000"/>
+              </a:solidFill>
+              <a:sym typeface="Open Sans"/>
+            </a:endParaRPr>
+          </a:p>
+          <a:p>
+            <a:pPr lvl="0" indent="0">
+              <a:buNone/>
+            </a:pPr>
+            <a:r>
+              <a:rPr lang="en-US" sz="1400" dirty="0">
+                <a:sym typeface="Open Sans"/>
+              </a:rPr>
+              <a:t>This approach ensures that only authorized users can access or update sensitive employee salary information.</a:t>
+            </a:r>
           </a:p>
           <a:p>
             <a:pPr marL="0" lvl="0" indent="0" algn="l" rtl="0">

</xml_diff>